<commit_message>
Add screenshot-based usage guide for the core build flow to presentation
Added 5 new slides with live screenshots (captured via Playwright against
the running app) and step-by-step "how to use" captions for the features
built/changed this session:

- Visual Builder: Templates panel + Auto-Build (NL -> workflow generation)
- Visual Builder: Agent Config (Local Model / Azure GPT-5.4-mini per-agent
  dropdown) + Export Code
- Visual Builder: Run dialog (AI-suggested input) + Deploy
- Architect (Prompt-to-Agent) + Agent Studio (agent list/management)
- Playground: Test Agent screen with the Suggest button and accurate
  per-agent model display

Deck is now 34 slides; verified page numbers are sequential end-to-end.
</commit_message>
<xml_diff>
--- a/docs/AgentForge-PresentationV8.pptx
+++ b/docs/AgentForge-PresentationV8.pptx
@@ -33,6 +33,11 @@
     <p:sldId id="282" r:id="rId32"/>
     <p:sldId id="283" r:id="rId33"/>
     <p:sldId id="284" r:id="rId34"/>
+    <p:sldId id="285" r:id="rId35"/>
+    <p:sldId id="286" r:id="rId36"/>
+    <p:sldId id="287" r:id="rId37"/>
+    <p:sldId id="288" r:id="rId38"/>
+    <p:sldId id="289" r:id="rId39"/>
     <p:sldId id="281" r:id="rId27"/>
   </p:sldIdLst>
   <p:sldSz cx="12188825" cy="6858000"/>
@@ -12604,7 +12609,7 @@
                   <a:srgbClr val="FFFFFF"/>
                 </a:solidFill>
               </a:rPr>
-              <a:t>1</a:t>
+              <a:t>14</a:t>
             </a:r>
           </a:p>
         </p:txBody>
@@ -13702,7 +13707,7 @@
                   <a:srgbClr val="FFFFFF"/>
                 </a:solidFill>
               </a:rPr>
-              <a:t>1</a:t>
+              <a:t>15</a:t>
             </a:r>
           </a:p>
         </p:txBody>
@@ -15569,7 +15574,7 @@
                   <a:srgbClr val="FFFFFF"/>
                 </a:solidFill>
               </a:rPr>
-              <a:t>1</a:t>
+              <a:t>16</a:t>
             </a:r>
           </a:p>
         </p:txBody>
@@ -31322,7 +31327,7 @@
                   <a:srgbClr val="CBD5E1"/>
                 </a:solidFill>
               </a:rPr>
-              <a:t>29</a:t>
+              <a:t>34</a:t>
             </a:r>
           </a:p>
         </p:txBody>
@@ -32176,6 +32181,1363 @@
                 </a:solidFill>
               </a:rPr>
               <a:t>3</a:t>
+            </a:r>
+          </a:p>
+        </p:txBody>
+      </p:sp>
+    </p:spTree>
+  </p:cSld>
+  <p:clrMapOvr>
+    <a:masterClrMapping/>
+  </p:clrMapOvr>
+</p:sld>
+</file>
+
+<file path=ppt/slides/slide30.xml><?xml version="1.0" encoding="utf-8"?>
+<p:sld xmlns:a="http://schemas.openxmlformats.org/drawingml/2006/main" xmlns:p="http://schemas.openxmlformats.org/presentationml/2006/main" xmlns:r="http://schemas.openxmlformats.org/officeDocument/2006/relationships">
+  <p:cSld>
+    <p:spTree>
+      <p:nvGrpSpPr>
+        <p:cNvPr id="1" name=""/>
+        <p:cNvGrpSpPr/>
+        <p:nvPr/>
+      </p:nvGrpSpPr>
+      <p:grpSpPr/>
+      <p:sp>
+        <p:nvSpPr>
+          <p:cNvPr id="2" name="Rectangle 1"/>
+          <p:cNvSpPr/>
+          <p:nvPr/>
+        </p:nvSpPr>
+        <p:spPr>
+          <a:xfrm>
+            <a:off x="0" y="0"/>
+            <a:ext cx="12188825" cy="6858000"/>
+          </a:xfrm>
+          <a:prstGeom prst="rect">
+            <a:avLst/>
+          </a:prstGeom>
+          <a:solidFill>
+            <a:srgbClr val="0F172A"/>
+          </a:solidFill>
+          <a:ln>
+            <a:noFill/>
+          </a:ln>
+          <a:effectLst/>
+        </p:spPr>
+        <p:style>
+          <a:lnRef idx="1">
+            <a:schemeClr val="accent1"/>
+          </a:lnRef>
+          <a:fillRef idx="3">
+            <a:schemeClr val="accent1"/>
+          </a:fillRef>
+          <a:effectRef idx="2">
+            <a:schemeClr val="accent1"/>
+          </a:effectRef>
+          <a:fontRef idx="minor">
+            <a:schemeClr val="lt1"/>
+          </a:fontRef>
+        </p:style>
+        <p:txBody>
+          <a:bodyPr rtlCol="0" anchor="ctr"/>
+          <a:lstStyle/>
+          <a:p>
+            <a:pPr algn="ctr"/>
+          </a:p>
+        </p:txBody>
+      </p:sp>
+      <p:sp>
+        <p:nvSpPr>
+          <p:cNvPr id="3" name="Rectangle 2"/>
+          <p:cNvSpPr/>
+          <p:nvPr/>
+        </p:nvSpPr>
+        <p:spPr>
+          <a:xfrm>
+            <a:off x="0" y="73152"/>
+            <a:ext cx="12188825" cy="45720"/>
+          </a:xfrm>
+          <a:prstGeom prst="rect">
+            <a:avLst/>
+          </a:prstGeom>
+          <a:solidFill>
+            <a:srgbClr val="606EF5"/>
+          </a:solidFill>
+          <a:ln>
+            <a:noFill/>
+          </a:ln>
+          <a:effectLst/>
+        </p:spPr>
+        <p:style>
+          <a:lnRef idx="1">
+            <a:schemeClr val="accent1"/>
+          </a:lnRef>
+          <a:fillRef idx="3">
+            <a:schemeClr val="accent1"/>
+          </a:fillRef>
+          <a:effectRef idx="2">
+            <a:schemeClr val="accent1"/>
+          </a:effectRef>
+          <a:fontRef idx="minor">
+            <a:schemeClr val="lt1"/>
+          </a:fontRef>
+        </p:style>
+        <p:txBody>
+          <a:bodyPr rtlCol="0" anchor="ctr"/>
+          <a:lstStyle/>
+          <a:p>
+            <a:pPr algn="ctr"/>
+          </a:p>
+        </p:txBody>
+      </p:sp>
+      <p:sp>
+        <p:nvSpPr>
+          <p:cNvPr id="4" name="TextBox 3"/>
+          <p:cNvSpPr txBox="1"/>
+          <p:nvPr/>
+        </p:nvSpPr>
+        <p:spPr>
+          <a:xfrm>
+            <a:off x="457200" y="274320"/>
+            <a:ext cx="10972800" cy="548640"/>
+          </a:xfrm>
+          <a:prstGeom prst="rect">
+            <a:avLst/>
+          </a:prstGeom>
+          <a:noFill/>
+        </p:spPr>
+        <p:txBody>
+          <a:bodyPr wrap="square">
+            <a:spAutoFit/>
+          </a:bodyPr>
+          <a:lstStyle/>
+          <a:p>
+            <a:r>
+              <a:rPr sz="2600" b="1">
+                <a:solidFill>
+                  <a:srgbClr val="FFFFFF"/>
+                </a:solidFill>
+              </a:rPr>
+              <a:t>How To Use: Visual Builder — Templates &amp; Auto-Build</a:t>
+            </a:r>
+          </a:p>
+        </p:txBody>
+      </p:sp>
+      <p:sp>
+        <p:nvSpPr>
+          <p:cNvPr id="5" name="TextBox 4"/>
+          <p:cNvSpPr txBox="1"/>
+          <p:nvPr/>
+        </p:nvSpPr>
+        <p:spPr>
+          <a:xfrm>
+            <a:off x="11731752" y="6492240"/>
+            <a:ext cx="457200" cy="320040"/>
+          </a:xfrm>
+          <a:prstGeom prst="rect">
+            <a:avLst/>
+          </a:prstGeom>
+          <a:noFill/>
+        </p:spPr>
+        <p:txBody>
+          <a:bodyPr wrap="none">
+            <a:spAutoFit/>
+          </a:bodyPr>
+          <a:lstStyle/>
+          <a:p>
+            <a:r>
+              <a:rPr sz="1100">
+                <a:solidFill>
+                  <a:srgbClr val="CBD5E1"/>
+                </a:solidFill>
+              </a:rPr>
+              <a:t>29</a:t>
+            </a:r>
+          </a:p>
+        </p:txBody>
+      </p:sp>
+      <p:pic>
+        <p:nvPicPr>
+          <p:cNvPr id="6" name="Picture 5" descr="02_builder_templates.png"/>
+          <p:cNvPicPr>
+            <a:picLocks noChangeAspect="1"/>
+          </p:cNvPicPr>
+          <p:nvPr/>
+        </p:nvPicPr>
+        <p:blipFill>
+          <a:blip r:embed="rId2"/>
+          <a:stretch>
+            <a:fillRect/>
+          </a:stretch>
+        </p:blipFill>
+        <p:spPr>
+          <a:xfrm>
+            <a:off x="457200" y="1051560"/>
+            <a:ext cx="5486400" cy="3086100"/>
+          </a:xfrm>
+          <a:prstGeom prst="rect">
+            <a:avLst/>
+          </a:prstGeom>
+          <a:ln w="12700">
+            <a:solidFill>
+              <a:srgbClr val="334155"/>
+            </a:solidFill>
+          </a:ln>
+        </p:spPr>
+      </p:pic>
+      <p:pic>
+        <p:nvPicPr>
+          <p:cNvPr id="7" name="Picture 6" descr="03_builder_autobuild.png"/>
+          <p:cNvPicPr>
+            <a:picLocks noChangeAspect="1"/>
+          </p:cNvPicPr>
+          <p:nvPr/>
+        </p:nvPicPr>
+        <p:blipFill>
+          <a:blip r:embed="rId3"/>
+          <a:stretch>
+            <a:fillRect/>
+          </a:stretch>
+        </p:blipFill>
+        <p:spPr>
+          <a:xfrm>
+            <a:off x="6172200" y="1051560"/>
+            <a:ext cx="5486400" cy="3086100"/>
+          </a:xfrm>
+          <a:prstGeom prst="rect">
+            <a:avLst/>
+          </a:prstGeom>
+          <a:ln w="12700">
+            <a:solidFill>
+              <a:srgbClr val="334155"/>
+            </a:solidFill>
+          </a:ln>
+        </p:spPr>
+      </p:pic>
+      <p:sp>
+        <p:nvSpPr>
+          <p:cNvPr id="8" name="TextBox 7"/>
+          <p:cNvSpPr txBox="1"/>
+          <p:nvPr/>
+        </p:nvSpPr>
+        <p:spPr>
+          <a:xfrm>
+            <a:off x="457200" y="5440680"/>
+            <a:ext cx="11247120" cy="1188720"/>
+          </a:xfrm>
+          <a:prstGeom prst="rect">
+            <a:avLst/>
+          </a:prstGeom>
+          <a:noFill/>
+        </p:spPr>
+        <p:txBody>
+          <a:bodyPr wrap="square">
+            <a:spAutoFit/>
+          </a:bodyPr>
+          <a:lstStyle/>
+          <a:p>
+            <a:pPr>
+              <a:spcAft>
+                <a:spcPts val="400"/>
+              </a:spcAft>
+            </a:pPr>
+            <a:r>
+              <a:rPr sz="1100">
+                <a:solidFill>
+                  <a:srgbClr val="CBD5E1"/>
+                </a:solidFill>
+              </a:rPr>
+              <a:t>① Templates — pick from 40+ ready-made multi-agent pipelines across 10 categories (Architecture, Sales &amp; Marketing, Customer Support, and more) and load one straight onto the canvas.</a:t>
+            </a:r>
+          </a:p>
+          <a:p>
+            <a:pPr>
+              <a:spcAft>
+                <a:spcPts val="400"/>
+              </a:spcAft>
+            </a:pPr>
+            <a:r>
+              <a:rPr sz="1100">
+                <a:solidFill>
+                  <a:srgbClr val="CBD5E1"/>
+                </a:solidFill>
+              </a:rPr>
+              <a:t>② Auto-Build — describe your pipeline in plain English (“A customer support pipeline that classifies queries, routes to the right responder...”) and GPT-5.4-mini generates a 3–6 role-typed node graph automatically.</a:t>
+            </a:r>
+          </a:p>
+        </p:txBody>
+      </p:sp>
+    </p:spTree>
+  </p:cSld>
+  <p:clrMapOvr>
+    <a:masterClrMapping/>
+  </p:clrMapOvr>
+</p:sld>
+</file>
+
+<file path=ppt/slides/slide31.xml><?xml version="1.0" encoding="utf-8"?>
+<p:sld xmlns:a="http://schemas.openxmlformats.org/drawingml/2006/main" xmlns:p="http://schemas.openxmlformats.org/presentationml/2006/main" xmlns:r="http://schemas.openxmlformats.org/officeDocument/2006/relationships">
+  <p:cSld>
+    <p:spTree>
+      <p:nvGrpSpPr>
+        <p:cNvPr id="1" name=""/>
+        <p:cNvGrpSpPr/>
+        <p:nvPr/>
+      </p:nvGrpSpPr>
+      <p:grpSpPr/>
+      <p:sp>
+        <p:nvSpPr>
+          <p:cNvPr id="2" name="Rectangle 1"/>
+          <p:cNvSpPr/>
+          <p:nvPr/>
+        </p:nvSpPr>
+        <p:spPr>
+          <a:xfrm>
+            <a:off x="0" y="0"/>
+            <a:ext cx="12188825" cy="6858000"/>
+          </a:xfrm>
+          <a:prstGeom prst="rect">
+            <a:avLst/>
+          </a:prstGeom>
+          <a:solidFill>
+            <a:srgbClr val="0F172A"/>
+          </a:solidFill>
+          <a:ln>
+            <a:noFill/>
+          </a:ln>
+          <a:effectLst/>
+        </p:spPr>
+        <p:style>
+          <a:lnRef idx="1">
+            <a:schemeClr val="accent1"/>
+          </a:lnRef>
+          <a:fillRef idx="3">
+            <a:schemeClr val="accent1"/>
+          </a:fillRef>
+          <a:effectRef idx="2">
+            <a:schemeClr val="accent1"/>
+          </a:effectRef>
+          <a:fontRef idx="minor">
+            <a:schemeClr val="lt1"/>
+          </a:fontRef>
+        </p:style>
+        <p:txBody>
+          <a:bodyPr rtlCol="0" anchor="ctr"/>
+          <a:lstStyle/>
+          <a:p>
+            <a:pPr algn="ctr"/>
+          </a:p>
+        </p:txBody>
+      </p:sp>
+      <p:sp>
+        <p:nvSpPr>
+          <p:cNvPr id="3" name="Rectangle 2"/>
+          <p:cNvSpPr/>
+          <p:nvPr/>
+        </p:nvSpPr>
+        <p:spPr>
+          <a:xfrm>
+            <a:off x="0" y="73152"/>
+            <a:ext cx="12188825" cy="45720"/>
+          </a:xfrm>
+          <a:prstGeom prst="rect">
+            <a:avLst/>
+          </a:prstGeom>
+          <a:solidFill>
+            <a:srgbClr val="606EF5"/>
+          </a:solidFill>
+          <a:ln>
+            <a:noFill/>
+          </a:ln>
+          <a:effectLst/>
+        </p:spPr>
+        <p:style>
+          <a:lnRef idx="1">
+            <a:schemeClr val="accent1"/>
+          </a:lnRef>
+          <a:fillRef idx="3">
+            <a:schemeClr val="accent1"/>
+          </a:fillRef>
+          <a:effectRef idx="2">
+            <a:schemeClr val="accent1"/>
+          </a:effectRef>
+          <a:fontRef idx="minor">
+            <a:schemeClr val="lt1"/>
+          </a:fontRef>
+        </p:style>
+        <p:txBody>
+          <a:bodyPr rtlCol="0" anchor="ctr"/>
+          <a:lstStyle/>
+          <a:p>
+            <a:pPr algn="ctr"/>
+          </a:p>
+        </p:txBody>
+      </p:sp>
+      <p:sp>
+        <p:nvSpPr>
+          <p:cNvPr id="4" name="TextBox 3"/>
+          <p:cNvSpPr txBox="1"/>
+          <p:nvPr/>
+        </p:nvSpPr>
+        <p:spPr>
+          <a:xfrm>
+            <a:off x="457200" y="274320"/>
+            <a:ext cx="10972800" cy="548640"/>
+          </a:xfrm>
+          <a:prstGeom prst="rect">
+            <a:avLst/>
+          </a:prstGeom>
+          <a:noFill/>
+        </p:spPr>
+        <p:txBody>
+          <a:bodyPr wrap="square">
+            <a:spAutoFit/>
+          </a:bodyPr>
+          <a:lstStyle/>
+          <a:p>
+            <a:r>
+              <a:rPr sz="2600" b="1">
+                <a:solidFill>
+                  <a:srgbClr val="FFFFFF"/>
+                </a:solidFill>
+              </a:rPr>
+              <a:t>How To Use: Visual Builder — Configure, Export &amp; Import</a:t>
+            </a:r>
+          </a:p>
+        </p:txBody>
+      </p:sp>
+      <p:sp>
+        <p:nvSpPr>
+          <p:cNvPr id="5" name="TextBox 4"/>
+          <p:cNvSpPr txBox="1"/>
+          <p:nvPr/>
+        </p:nvSpPr>
+        <p:spPr>
+          <a:xfrm>
+            <a:off x="11731752" y="6492240"/>
+            <a:ext cx="457200" cy="320040"/>
+          </a:xfrm>
+          <a:prstGeom prst="rect">
+            <a:avLst/>
+          </a:prstGeom>
+          <a:noFill/>
+        </p:spPr>
+        <p:txBody>
+          <a:bodyPr wrap="none">
+            <a:spAutoFit/>
+          </a:bodyPr>
+          <a:lstStyle/>
+          <a:p>
+            <a:r>
+              <a:rPr sz="1100">
+                <a:solidFill>
+                  <a:srgbClr val="CBD5E1"/>
+                </a:solidFill>
+              </a:rPr>
+              <a:t>30</a:t>
+            </a:r>
+          </a:p>
+        </p:txBody>
+      </p:sp>
+      <p:pic>
+        <p:nvPicPr>
+          <p:cNvPr id="6" name="Picture 5" descr="04_builder_agent_config.png"/>
+          <p:cNvPicPr>
+            <a:picLocks noChangeAspect="1"/>
+          </p:cNvPicPr>
+          <p:nvPr/>
+        </p:nvPicPr>
+        <p:blipFill>
+          <a:blip r:embed="rId2"/>
+          <a:stretch>
+            <a:fillRect/>
+          </a:stretch>
+        </p:blipFill>
+        <p:spPr>
+          <a:xfrm>
+            <a:off x="457200" y="1051560"/>
+            <a:ext cx="5486400" cy="3086100"/>
+          </a:xfrm>
+          <a:prstGeom prst="rect">
+            <a:avLst/>
+          </a:prstGeom>
+          <a:ln w="12700">
+            <a:solidFill>
+              <a:srgbClr val="334155"/>
+            </a:solidFill>
+          </a:ln>
+        </p:spPr>
+      </p:pic>
+      <p:pic>
+        <p:nvPicPr>
+          <p:cNvPr id="7" name="Picture 6" descr="05_builder_export_code.png"/>
+          <p:cNvPicPr>
+            <a:picLocks noChangeAspect="1"/>
+          </p:cNvPicPr>
+          <p:nvPr/>
+        </p:nvPicPr>
+        <p:blipFill>
+          <a:blip r:embed="rId3"/>
+          <a:stretch>
+            <a:fillRect/>
+          </a:stretch>
+        </p:blipFill>
+        <p:spPr>
+          <a:xfrm>
+            <a:off x="6172200" y="1051560"/>
+            <a:ext cx="5486400" cy="3086100"/>
+          </a:xfrm>
+          <a:prstGeom prst="rect">
+            <a:avLst/>
+          </a:prstGeom>
+          <a:ln w="12700">
+            <a:solidFill>
+              <a:srgbClr val="334155"/>
+            </a:solidFill>
+          </a:ln>
+        </p:spPr>
+      </p:pic>
+      <p:sp>
+        <p:nvSpPr>
+          <p:cNvPr id="8" name="TextBox 7"/>
+          <p:cNvSpPr txBox="1"/>
+          <p:nvPr/>
+        </p:nvSpPr>
+        <p:spPr>
+          <a:xfrm>
+            <a:off x="457200" y="5440680"/>
+            <a:ext cx="11247120" cy="1188720"/>
+          </a:xfrm>
+          <a:prstGeom prst="rect">
+            <a:avLst/>
+          </a:prstGeom>
+          <a:noFill/>
+        </p:spPr>
+        <p:txBody>
+          <a:bodyPr wrap="square">
+            <a:spAutoFit/>
+          </a:bodyPr>
+          <a:lstStyle/>
+          <a:p>
+            <a:pPr>
+              <a:spcAft>
+                <a:spcPts val="400"/>
+              </a:spcAft>
+            </a:pPr>
+            <a:r>
+              <a:rPr sz="1100">
+                <a:solidFill>
+                  <a:srgbClr val="CBD5E1"/>
+                </a:solidFill>
+              </a:rPr>
+              <a:t>① Configure — click any node to set its Role, System Prompt, Model (Local Model or Azure GPT-5.4-mini, per agent), Tools, and always-on Guardrails, then Save Agent.</a:t>
+            </a:r>
+          </a:p>
+          <a:p>
+            <a:pPr>
+              <a:spcAft>
+                <a:spcPts val="400"/>
+              </a:spcAft>
+            </a:pPr>
+            <a:r>
+              <a:rPr sz="1100">
+                <a:solidFill>
+                  <a:srgbClr val="CBD5E1"/>
+                </a:solidFill>
+              </a:rPr>
+              <a:t>② Export / Import — Export Code generates a faithful Python script with the same execution logic as the live engine; Export JSON / Import JSON give a lossless, round-trippable workflow backup.</a:t>
+            </a:r>
+          </a:p>
+        </p:txBody>
+      </p:sp>
+    </p:spTree>
+  </p:cSld>
+  <p:clrMapOvr>
+    <a:masterClrMapping/>
+  </p:clrMapOvr>
+</p:sld>
+</file>
+
+<file path=ppt/slides/slide32.xml><?xml version="1.0" encoding="utf-8"?>
+<p:sld xmlns:a="http://schemas.openxmlformats.org/drawingml/2006/main" xmlns:p="http://schemas.openxmlformats.org/presentationml/2006/main" xmlns:r="http://schemas.openxmlformats.org/officeDocument/2006/relationships">
+  <p:cSld>
+    <p:spTree>
+      <p:nvGrpSpPr>
+        <p:cNvPr id="1" name=""/>
+        <p:cNvGrpSpPr/>
+        <p:nvPr/>
+      </p:nvGrpSpPr>
+      <p:grpSpPr/>
+      <p:sp>
+        <p:nvSpPr>
+          <p:cNvPr id="2" name="Rectangle 1"/>
+          <p:cNvSpPr/>
+          <p:nvPr/>
+        </p:nvSpPr>
+        <p:spPr>
+          <a:xfrm>
+            <a:off x="0" y="0"/>
+            <a:ext cx="12188825" cy="6858000"/>
+          </a:xfrm>
+          <a:prstGeom prst="rect">
+            <a:avLst/>
+          </a:prstGeom>
+          <a:solidFill>
+            <a:srgbClr val="0F172A"/>
+          </a:solidFill>
+          <a:ln>
+            <a:noFill/>
+          </a:ln>
+          <a:effectLst/>
+        </p:spPr>
+        <p:style>
+          <a:lnRef idx="1">
+            <a:schemeClr val="accent1"/>
+          </a:lnRef>
+          <a:fillRef idx="3">
+            <a:schemeClr val="accent1"/>
+          </a:fillRef>
+          <a:effectRef idx="2">
+            <a:schemeClr val="accent1"/>
+          </a:effectRef>
+          <a:fontRef idx="minor">
+            <a:schemeClr val="lt1"/>
+          </a:fontRef>
+        </p:style>
+        <p:txBody>
+          <a:bodyPr rtlCol="0" anchor="ctr"/>
+          <a:lstStyle/>
+          <a:p>
+            <a:pPr algn="ctr"/>
+          </a:p>
+        </p:txBody>
+      </p:sp>
+      <p:sp>
+        <p:nvSpPr>
+          <p:cNvPr id="3" name="Rectangle 2"/>
+          <p:cNvSpPr/>
+          <p:nvPr/>
+        </p:nvSpPr>
+        <p:spPr>
+          <a:xfrm>
+            <a:off x="0" y="73152"/>
+            <a:ext cx="12188825" cy="45720"/>
+          </a:xfrm>
+          <a:prstGeom prst="rect">
+            <a:avLst/>
+          </a:prstGeom>
+          <a:solidFill>
+            <a:srgbClr val="606EF5"/>
+          </a:solidFill>
+          <a:ln>
+            <a:noFill/>
+          </a:ln>
+          <a:effectLst/>
+        </p:spPr>
+        <p:style>
+          <a:lnRef idx="1">
+            <a:schemeClr val="accent1"/>
+          </a:lnRef>
+          <a:fillRef idx="3">
+            <a:schemeClr val="accent1"/>
+          </a:fillRef>
+          <a:effectRef idx="2">
+            <a:schemeClr val="accent1"/>
+          </a:effectRef>
+          <a:fontRef idx="minor">
+            <a:schemeClr val="lt1"/>
+          </a:fontRef>
+        </p:style>
+        <p:txBody>
+          <a:bodyPr rtlCol="0" anchor="ctr"/>
+          <a:lstStyle/>
+          <a:p>
+            <a:pPr algn="ctr"/>
+          </a:p>
+        </p:txBody>
+      </p:sp>
+      <p:sp>
+        <p:nvSpPr>
+          <p:cNvPr id="4" name="TextBox 3"/>
+          <p:cNvSpPr txBox="1"/>
+          <p:nvPr/>
+        </p:nvSpPr>
+        <p:spPr>
+          <a:xfrm>
+            <a:off x="457200" y="274320"/>
+            <a:ext cx="10972800" cy="548640"/>
+          </a:xfrm>
+          <a:prstGeom prst="rect">
+            <a:avLst/>
+          </a:prstGeom>
+          <a:noFill/>
+        </p:spPr>
+        <p:txBody>
+          <a:bodyPr wrap="square">
+            <a:spAutoFit/>
+          </a:bodyPr>
+          <a:lstStyle/>
+          <a:p>
+            <a:r>
+              <a:rPr sz="2600" b="1">
+                <a:solidFill>
+                  <a:srgbClr val="FFFFFF"/>
+                </a:solidFill>
+              </a:rPr>
+              <a:t>How To Use: Visual Builder — Run &amp; Deploy</a:t>
+            </a:r>
+          </a:p>
+        </p:txBody>
+      </p:sp>
+      <p:sp>
+        <p:nvSpPr>
+          <p:cNvPr id="5" name="TextBox 4"/>
+          <p:cNvSpPr txBox="1"/>
+          <p:nvPr/>
+        </p:nvSpPr>
+        <p:spPr>
+          <a:xfrm>
+            <a:off x="11731752" y="6492240"/>
+            <a:ext cx="457200" cy="320040"/>
+          </a:xfrm>
+          <a:prstGeom prst="rect">
+            <a:avLst/>
+          </a:prstGeom>
+          <a:noFill/>
+        </p:spPr>
+        <p:txBody>
+          <a:bodyPr wrap="none">
+            <a:spAutoFit/>
+          </a:bodyPr>
+          <a:lstStyle/>
+          <a:p>
+            <a:r>
+              <a:rPr sz="1100">
+                <a:solidFill>
+                  <a:srgbClr val="CBD5E1"/>
+                </a:solidFill>
+              </a:rPr>
+              <a:t>31</a:t>
+            </a:r>
+          </a:p>
+        </p:txBody>
+      </p:sp>
+      <p:pic>
+        <p:nvPicPr>
+          <p:cNvPr id="6" name="Picture 5" descr="06_builder_run_dialog.png"/>
+          <p:cNvPicPr>
+            <a:picLocks noChangeAspect="1"/>
+          </p:cNvPicPr>
+          <p:nvPr/>
+        </p:nvPicPr>
+        <p:blipFill>
+          <a:blip r:embed="rId2"/>
+          <a:stretch>
+            <a:fillRect/>
+          </a:stretch>
+        </p:blipFill>
+        <p:spPr>
+          <a:xfrm>
+            <a:off x="2651760" y="1051560"/>
+            <a:ext cx="6858000" cy="3857625"/>
+          </a:xfrm>
+          <a:prstGeom prst="rect">
+            <a:avLst/>
+          </a:prstGeom>
+          <a:ln w="12700">
+            <a:solidFill>
+              <a:srgbClr val="334155"/>
+            </a:solidFill>
+          </a:ln>
+        </p:spPr>
+      </p:pic>
+      <p:sp>
+        <p:nvSpPr>
+          <p:cNvPr id="7" name="TextBox 6"/>
+          <p:cNvSpPr txBox="1"/>
+          <p:nvPr/>
+        </p:nvSpPr>
+        <p:spPr>
+          <a:xfrm>
+            <a:off x="457200" y="5440680"/>
+            <a:ext cx="11247120" cy="1188720"/>
+          </a:xfrm>
+          <a:prstGeom prst="rect">
+            <a:avLst/>
+          </a:prstGeom>
+          <a:noFill/>
+        </p:spPr>
+        <p:txBody>
+          <a:bodyPr wrap="square">
+            <a:spAutoFit/>
+          </a:bodyPr>
+          <a:lstStyle/>
+          <a:p>
+            <a:pPr>
+              <a:spcAft>
+                <a:spcPts val="400"/>
+              </a:spcAft>
+            </a:pPr>
+            <a:r>
+              <a:rPr sz="1100">
+                <a:solidFill>
+                  <a:srgbClr val="CBD5E1"/>
+                </a:solidFill>
+              </a:rPr>
+              <a:t>① Run — click Run, and an AI-suggested realistic example input is generated automatically; edit it or keep it, then Execute &amp; Save Trace to watch each node pulse green while running and stay green when done.</a:t>
+            </a:r>
+          </a:p>
+          <a:p>
+            <a:pPr>
+              <a:spcAft>
+                <a:spcPts val="400"/>
+              </a:spcAft>
+            </a:pPr>
+            <a:r>
+              <a:rPr sz="1100">
+                <a:solidFill>
+                  <a:srgbClr val="CBD5E1"/>
+                </a:solidFill>
+              </a:rPr>
+              <a:t>② Deploy — publish the workflow as a live, callable endpoint once you're happy with a run's trace in Workflow Runs / Observability.</a:t>
+            </a:r>
+          </a:p>
+        </p:txBody>
+      </p:sp>
+    </p:spTree>
+  </p:cSld>
+  <p:clrMapOvr>
+    <a:masterClrMapping/>
+  </p:clrMapOvr>
+</p:sld>
+</file>
+
+<file path=ppt/slides/slide33.xml><?xml version="1.0" encoding="utf-8"?>
+<p:sld xmlns:a="http://schemas.openxmlformats.org/drawingml/2006/main" xmlns:p="http://schemas.openxmlformats.org/presentationml/2006/main" xmlns:r="http://schemas.openxmlformats.org/officeDocument/2006/relationships">
+  <p:cSld>
+    <p:spTree>
+      <p:nvGrpSpPr>
+        <p:cNvPr id="1" name=""/>
+        <p:cNvGrpSpPr/>
+        <p:nvPr/>
+      </p:nvGrpSpPr>
+      <p:grpSpPr/>
+      <p:sp>
+        <p:nvSpPr>
+          <p:cNvPr id="2" name="Rectangle 1"/>
+          <p:cNvSpPr/>
+          <p:nvPr/>
+        </p:nvSpPr>
+        <p:spPr>
+          <a:xfrm>
+            <a:off x="0" y="0"/>
+            <a:ext cx="12188825" cy="6858000"/>
+          </a:xfrm>
+          <a:prstGeom prst="rect">
+            <a:avLst/>
+          </a:prstGeom>
+          <a:solidFill>
+            <a:srgbClr val="0F172A"/>
+          </a:solidFill>
+          <a:ln>
+            <a:noFill/>
+          </a:ln>
+          <a:effectLst/>
+        </p:spPr>
+        <p:style>
+          <a:lnRef idx="1">
+            <a:schemeClr val="accent1"/>
+          </a:lnRef>
+          <a:fillRef idx="3">
+            <a:schemeClr val="accent1"/>
+          </a:fillRef>
+          <a:effectRef idx="2">
+            <a:schemeClr val="accent1"/>
+          </a:effectRef>
+          <a:fontRef idx="minor">
+            <a:schemeClr val="lt1"/>
+          </a:fontRef>
+        </p:style>
+        <p:txBody>
+          <a:bodyPr rtlCol="0" anchor="ctr"/>
+          <a:lstStyle/>
+          <a:p>
+            <a:pPr algn="ctr"/>
+          </a:p>
+        </p:txBody>
+      </p:sp>
+      <p:sp>
+        <p:nvSpPr>
+          <p:cNvPr id="3" name="Rectangle 2"/>
+          <p:cNvSpPr/>
+          <p:nvPr/>
+        </p:nvSpPr>
+        <p:spPr>
+          <a:xfrm>
+            <a:off x="0" y="73152"/>
+            <a:ext cx="12188825" cy="45720"/>
+          </a:xfrm>
+          <a:prstGeom prst="rect">
+            <a:avLst/>
+          </a:prstGeom>
+          <a:solidFill>
+            <a:srgbClr val="606EF5"/>
+          </a:solidFill>
+          <a:ln>
+            <a:noFill/>
+          </a:ln>
+          <a:effectLst/>
+        </p:spPr>
+        <p:style>
+          <a:lnRef idx="1">
+            <a:schemeClr val="accent1"/>
+          </a:lnRef>
+          <a:fillRef idx="3">
+            <a:schemeClr val="accent1"/>
+          </a:fillRef>
+          <a:effectRef idx="2">
+            <a:schemeClr val="accent1"/>
+          </a:effectRef>
+          <a:fontRef idx="minor">
+            <a:schemeClr val="lt1"/>
+          </a:fontRef>
+        </p:style>
+        <p:txBody>
+          <a:bodyPr rtlCol="0" anchor="ctr"/>
+          <a:lstStyle/>
+          <a:p>
+            <a:pPr algn="ctr"/>
+          </a:p>
+        </p:txBody>
+      </p:sp>
+      <p:sp>
+        <p:nvSpPr>
+          <p:cNvPr id="4" name="TextBox 3"/>
+          <p:cNvSpPr txBox="1"/>
+          <p:nvPr/>
+        </p:nvSpPr>
+        <p:spPr>
+          <a:xfrm>
+            <a:off x="457200" y="274320"/>
+            <a:ext cx="10972800" cy="548640"/>
+          </a:xfrm>
+          <a:prstGeom prst="rect">
+            <a:avLst/>
+          </a:prstGeom>
+          <a:noFill/>
+        </p:spPr>
+        <p:txBody>
+          <a:bodyPr wrap="square">
+            <a:spAutoFit/>
+          </a:bodyPr>
+          <a:lstStyle/>
+          <a:p>
+            <a:r>
+              <a:rPr sz="2600" b="1">
+                <a:solidFill>
+                  <a:srgbClr val="FFFFFF"/>
+                </a:solidFill>
+              </a:rPr>
+              <a:t>How To Use: Architect, Agent Studio &amp; Playground</a:t>
+            </a:r>
+          </a:p>
+        </p:txBody>
+      </p:sp>
+      <p:sp>
+        <p:nvSpPr>
+          <p:cNvPr id="5" name="TextBox 4"/>
+          <p:cNvSpPr txBox="1"/>
+          <p:nvPr/>
+        </p:nvSpPr>
+        <p:spPr>
+          <a:xfrm>
+            <a:off x="11731752" y="6492240"/>
+            <a:ext cx="457200" cy="320040"/>
+          </a:xfrm>
+          <a:prstGeom prst="rect">
+            <a:avLst/>
+          </a:prstGeom>
+          <a:noFill/>
+        </p:spPr>
+        <p:txBody>
+          <a:bodyPr wrap="none">
+            <a:spAutoFit/>
+          </a:bodyPr>
+          <a:lstStyle/>
+          <a:p>
+            <a:r>
+              <a:rPr sz="1100">
+                <a:solidFill>
+                  <a:srgbClr val="CBD5E1"/>
+                </a:solidFill>
+              </a:rPr>
+              <a:t>32</a:t>
+            </a:r>
+          </a:p>
+        </p:txBody>
+      </p:sp>
+      <p:pic>
+        <p:nvPicPr>
+          <p:cNvPr id="6" name="Picture 5" descr="07_architect.png"/>
+          <p:cNvPicPr>
+            <a:picLocks noChangeAspect="1"/>
+          </p:cNvPicPr>
+          <p:nvPr/>
+        </p:nvPicPr>
+        <p:blipFill>
+          <a:blip r:embed="rId2"/>
+          <a:stretch>
+            <a:fillRect/>
+          </a:stretch>
+        </p:blipFill>
+        <p:spPr>
+          <a:xfrm>
+            <a:off x="457200" y="1051560"/>
+            <a:ext cx="5486400" cy="3086100"/>
+          </a:xfrm>
+          <a:prstGeom prst="rect">
+            <a:avLst/>
+          </a:prstGeom>
+          <a:ln w="12700">
+            <a:solidFill>
+              <a:srgbClr val="334155"/>
+            </a:solidFill>
+          </a:ln>
+        </p:spPr>
+      </p:pic>
+      <p:pic>
+        <p:nvPicPr>
+          <p:cNvPr id="7" name="Picture 6" descr="08_agent_studio.png"/>
+          <p:cNvPicPr>
+            <a:picLocks noChangeAspect="1"/>
+          </p:cNvPicPr>
+          <p:nvPr/>
+        </p:nvPicPr>
+        <p:blipFill>
+          <a:blip r:embed="rId3"/>
+          <a:stretch>
+            <a:fillRect/>
+          </a:stretch>
+        </p:blipFill>
+        <p:spPr>
+          <a:xfrm>
+            <a:off x="6172200" y="1051560"/>
+            <a:ext cx="5486400" cy="3086100"/>
+          </a:xfrm>
+          <a:prstGeom prst="rect">
+            <a:avLst/>
+          </a:prstGeom>
+          <a:ln w="12700">
+            <a:solidFill>
+              <a:srgbClr val="334155"/>
+            </a:solidFill>
+          </a:ln>
+        </p:spPr>
+      </p:pic>
+      <p:sp>
+        <p:nvSpPr>
+          <p:cNvPr id="8" name="TextBox 7"/>
+          <p:cNvSpPr txBox="1"/>
+          <p:nvPr/>
+        </p:nvSpPr>
+        <p:spPr>
+          <a:xfrm>
+            <a:off x="457200" y="5440680"/>
+            <a:ext cx="11247120" cy="1188720"/>
+          </a:xfrm>
+          <a:prstGeom prst="rect">
+            <a:avLst/>
+          </a:prstGeom>
+          <a:noFill/>
+        </p:spPr>
+        <p:txBody>
+          <a:bodyPr wrap="square">
+            <a:spAutoFit/>
+          </a:bodyPr>
+          <a:lstStyle/>
+          <a:p>
+            <a:pPr>
+              <a:spcAft>
+                <a:spcPts val="400"/>
+              </a:spcAft>
+            </a:pPr>
+            <a:r>
+              <a:rPr sz="1100">
+                <a:solidFill>
+                  <a:srgbClr val="CBD5E1"/>
+                </a:solidFill>
+              </a:rPr>
+              <a:t>① Architect — describe what you want to build in plain English; it asks clarifying questions, then generates a full Plan / Agents / App / Database, downloadable as a RAG Scaffold or Custom Code ZIP.</a:t>
+            </a:r>
+          </a:p>
+          <a:p>
+            <a:pPr>
+              <a:spcAft>
+                <a:spcPts val="400"/>
+              </a:spcAft>
+            </a:pPr>
+            <a:r>
+              <a:rPr sz="1100">
+                <a:solidFill>
+                  <a:srgbClr val="CBD5E1"/>
+                </a:solidFill>
+              </a:rPr>
+              <a:t>② Agent Studio — every saved agent lives here: Edit, Test, Deploy, Publish, or ask it something directly. Playground gives each agent its own chat with a one-click “Suggest” example-input button.</a:t>
+            </a:r>
+          </a:p>
+        </p:txBody>
+      </p:sp>
+    </p:spTree>
+  </p:cSld>
+  <p:clrMapOvr>
+    <a:masterClrMapping/>
+  </p:clrMapOvr>
+</p:sld>
+</file>
+
+<file path=ppt/slides/slide34.xml><?xml version="1.0" encoding="utf-8"?>
+<p:sld xmlns:a="http://schemas.openxmlformats.org/drawingml/2006/main" xmlns:p="http://schemas.openxmlformats.org/presentationml/2006/main" xmlns:r="http://schemas.openxmlformats.org/officeDocument/2006/relationships">
+  <p:cSld>
+    <p:spTree>
+      <p:nvGrpSpPr>
+        <p:cNvPr id="1" name=""/>
+        <p:cNvGrpSpPr/>
+        <p:nvPr/>
+      </p:nvGrpSpPr>
+      <p:grpSpPr/>
+      <p:sp>
+        <p:nvSpPr>
+          <p:cNvPr id="2" name="Rectangle 1"/>
+          <p:cNvSpPr/>
+          <p:nvPr/>
+        </p:nvSpPr>
+        <p:spPr>
+          <a:xfrm>
+            <a:off x="0" y="0"/>
+            <a:ext cx="12188825" cy="6858000"/>
+          </a:xfrm>
+          <a:prstGeom prst="rect">
+            <a:avLst/>
+          </a:prstGeom>
+          <a:solidFill>
+            <a:srgbClr val="0F172A"/>
+          </a:solidFill>
+          <a:ln>
+            <a:noFill/>
+          </a:ln>
+          <a:effectLst/>
+        </p:spPr>
+        <p:style>
+          <a:lnRef idx="1">
+            <a:schemeClr val="accent1"/>
+          </a:lnRef>
+          <a:fillRef idx="3">
+            <a:schemeClr val="accent1"/>
+          </a:fillRef>
+          <a:effectRef idx="2">
+            <a:schemeClr val="accent1"/>
+          </a:effectRef>
+          <a:fontRef idx="minor">
+            <a:schemeClr val="lt1"/>
+          </a:fontRef>
+        </p:style>
+        <p:txBody>
+          <a:bodyPr rtlCol="0" anchor="ctr"/>
+          <a:lstStyle/>
+          <a:p>
+            <a:pPr algn="ctr"/>
+          </a:p>
+        </p:txBody>
+      </p:sp>
+      <p:sp>
+        <p:nvSpPr>
+          <p:cNvPr id="3" name="Rectangle 2"/>
+          <p:cNvSpPr/>
+          <p:nvPr/>
+        </p:nvSpPr>
+        <p:spPr>
+          <a:xfrm>
+            <a:off x="0" y="73152"/>
+            <a:ext cx="12188825" cy="45720"/>
+          </a:xfrm>
+          <a:prstGeom prst="rect">
+            <a:avLst/>
+          </a:prstGeom>
+          <a:solidFill>
+            <a:srgbClr val="606EF5"/>
+          </a:solidFill>
+          <a:ln>
+            <a:noFill/>
+          </a:ln>
+          <a:effectLst/>
+        </p:spPr>
+        <p:style>
+          <a:lnRef idx="1">
+            <a:schemeClr val="accent1"/>
+          </a:lnRef>
+          <a:fillRef idx="3">
+            <a:schemeClr val="accent1"/>
+          </a:fillRef>
+          <a:effectRef idx="2">
+            <a:schemeClr val="accent1"/>
+          </a:effectRef>
+          <a:fontRef idx="minor">
+            <a:schemeClr val="lt1"/>
+          </a:fontRef>
+        </p:style>
+        <p:txBody>
+          <a:bodyPr rtlCol="0" anchor="ctr"/>
+          <a:lstStyle/>
+          <a:p>
+            <a:pPr algn="ctr"/>
+          </a:p>
+        </p:txBody>
+      </p:sp>
+      <p:sp>
+        <p:nvSpPr>
+          <p:cNvPr id="4" name="TextBox 3"/>
+          <p:cNvSpPr txBox="1"/>
+          <p:nvPr/>
+        </p:nvSpPr>
+        <p:spPr>
+          <a:xfrm>
+            <a:off x="457200" y="274320"/>
+            <a:ext cx="10972800" cy="548640"/>
+          </a:xfrm>
+          <a:prstGeom prst="rect">
+            <a:avLst/>
+          </a:prstGeom>
+          <a:noFill/>
+        </p:spPr>
+        <p:txBody>
+          <a:bodyPr wrap="square">
+            <a:spAutoFit/>
+          </a:bodyPr>
+          <a:lstStyle/>
+          <a:p>
+            <a:r>
+              <a:rPr sz="2600" b="1">
+                <a:solidFill>
+                  <a:srgbClr val="FFFFFF"/>
+                </a:solidFill>
+              </a:rPr>
+              <a:t>How To Use: Playground — Test Any Agent Live</a:t>
+            </a:r>
+          </a:p>
+        </p:txBody>
+      </p:sp>
+      <p:sp>
+        <p:nvSpPr>
+          <p:cNvPr id="5" name="TextBox 4"/>
+          <p:cNvSpPr txBox="1"/>
+          <p:nvPr/>
+        </p:nvSpPr>
+        <p:spPr>
+          <a:xfrm>
+            <a:off x="11731752" y="6492240"/>
+            <a:ext cx="457200" cy="320040"/>
+          </a:xfrm>
+          <a:prstGeom prst="rect">
+            <a:avLst/>
+          </a:prstGeom>
+          <a:noFill/>
+        </p:spPr>
+        <p:txBody>
+          <a:bodyPr wrap="none">
+            <a:spAutoFit/>
+          </a:bodyPr>
+          <a:lstStyle/>
+          <a:p>
+            <a:r>
+              <a:rPr sz="1100">
+                <a:solidFill>
+                  <a:srgbClr val="CBD5E1"/>
+                </a:solidFill>
+              </a:rPr>
+              <a:t>33</a:t>
+            </a:r>
+          </a:p>
+        </p:txBody>
+      </p:sp>
+      <p:pic>
+        <p:nvPicPr>
+          <p:cNvPr id="6" name="Picture 5" descr="10_playground_suggest.png"/>
+          <p:cNvPicPr>
+            <a:picLocks noChangeAspect="1"/>
+          </p:cNvPicPr>
+          <p:nvPr/>
+        </p:nvPicPr>
+        <p:blipFill>
+          <a:blip r:embed="rId2"/>
+          <a:stretch>
+            <a:fillRect/>
+          </a:stretch>
+        </p:blipFill>
+        <p:spPr>
+          <a:xfrm>
+            <a:off x="2651760" y="1051560"/>
+            <a:ext cx="6858000" cy="3857625"/>
+          </a:xfrm>
+          <a:prstGeom prst="rect">
+            <a:avLst/>
+          </a:prstGeom>
+          <a:ln w="12700">
+            <a:solidFill>
+              <a:srgbClr val="334155"/>
+            </a:solidFill>
+          </a:ln>
+        </p:spPr>
+      </p:pic>
+      <p:sp>
+        <p:nvSpPr>
+          <p:cNvPr id="7" name="TextBox 6"/>
+          <p:cNvSpPr txBox="1"/>
+          <p:nvPr/>
+        </p:nvSpPr>
+        <p:spPr>
+          <a:xfrm>
+            <a:off x="457200" y="5440680"/>
+            <a:ext cx="11247120" cy="1188720"/>
+          </a:xfrm>
+          <a:prstGeom prst="rect">
+            <a:avLst/>
+          </a:prstGeom>
+          <a:noFill/>
+        </p:spPr>
+        <p:txBody>
+          <a:bodyPr wrap="square">
+            <a:spAutoFit/>
+          </a:bodyPr>
+          <a:lstStyle/>
+          <a:p>
+            <a:pPr>
+              <a:spcAft>
+                <a:spcPts val="400"/>
+              </a:spcAft>
+            </a:pPr>
+            <a:r>
+              <a:rPr sz="1100">
+                <a:solidFill>
+                  <a:srgbClr val="CBD5E1"/>
+                </a:solidFill>
+              </a:rPr>
+              <a:t>① Open any agent's Playground to see its System Prompt, Guardrails, Tools, and the exact Model it runs on (accurately resolved per agent — Local Model or Azure GPT-5.4-mini, not a stale label).</a:t>
+            </a:r>
+          </a:p>
+          <a:p>
+            <a:pPr>
+              <a:spcAft>
+                <a:spcPts val="400"/>
+              </a:spcAft>
+            </a:pPr>
+            <a:r>
+              <a:rPr sz="1100">
+                <a:solidFill>
+                  <a:srgbClr val="CBD5E1"/>
+                </a:solidFill>
+              </a:rPr>
+              <a:t>② Click Suggest for an AI-generated realistic example message tailored to that agent, or type your own — then Send to test it live and watch Session Stats (Total Runs, Avg ms) update.</a:t>
             </a:r>
           </a:p>
         </p:txBody>

</xml_diff>

<commit_message>
Add Home, Prompt Library, Control Plane, Traceability, and Observability slides
Extends the screenshot-based usage guide with 5 more slides (deck is now
37 slides):
- Home & Prompt Library
- Control Plane & Usage/Audit Traceability
- Workflow Observability (real trace data: run counts, status, duration)

Also fixed a stale Playground screenshot that showed the raw "local"
choice instead of the resolved model name -- the underlying dropdown
feature was correct, the first screenshot capture just raced ahead of
the async model-resolution fetch.
</commit_message>
<xml_diff>
--- a/docs/AgentForge-PresentationV8.pptx
+++ b/docs/AgentForge-PresentationV8.pptx
@@ -30,15 +30,18 @@
     <p:sldId id="278" r:id="rId24"/>
     <p:sldId id="279" r:id="rId25"/>
     <p:sldId id="280" r:id="rId26"/>
-    <p:sldId id="282" r:id="rId32"/>
-    <p:sldId id="283" r:id="rId33"/>
-    <p:sldId id="284" r:id="rId34"/>
-    <p:sldId id="285" r:id="rId35"/>
-    <p:sldId id="286" r:id="rId36"/>
-    <p:sldId id="287" r:id="rId37"/>
-    <p:sldId id="288" r:id="rId38"/>
-    <p:sldId id="289" r:id="rId39"/>
-    <p:sldId id="281" r:id="rId27"/>
+    <p:sldId id="282" r:id="rId27"/>
+    <p:sldId id="283" r:id="rId28"/>
+    <p:sldId id="284" r:id="rId29"/>
+    <p:sldId id="285" r:id="rId30"/>
+    <p:sldId id="286" r:id="rId31"/>
+    <p:sldId id="287" r:id="rId32"/>
+    <p:sldId id="288" r:id="rId33"/>
+    <p:sldId id="289" r:id="rId34"/>
+    <p:sldId id="290" r:id="rId40"/>
+    <p:sldId id="291" r:id="rId41"/>
+    <p:sldId id="292" r:id="rId42"/>
+    <p:sldId id="281" r:id="rId35"/>
   </p:sldIdLst>
   <p:sldSz cx="12188825" cy="6858000"/>
   <p:notesSz cx="6858000" cy="9144000"/>
@@ -335,7 +338,7 @@
           <a:p>
             <a:fld id="{5BCAD085-E8A6-8845-BD4E-CB4CCA059FC4}" type="datetimeFigureOut">
               <a:rPr lang="en-US" smtClean="0"/>
-              <a:t>7/18/2026</a:t>
+              <a:t>7/20/2026</a:t>
             </a:fld>
             <a:endParaRPr lang="en-US"/>
           </a:p>
@@ -503,7 +506,7 @@
           <a:p>
             <a:fld id="{5BCAD085-E8A6-8845-BD4E-CB4CCA059FC4}" type="datetimeFigureOut">
               <a:rPr lang="en-US" smtClean="0"/>
-              <a:t>7/18/2026</a:t>
+              <a:t>7/20/2026</a:t>
             </a:fld>
             <a:endParaRPr lang="en-US"/>
           </a:p>
@@ -681,7 +684,7 @@
           <a:p>
             <a:fld id="{5BCAD085-E8A6-8845-BD4E-CB4CCA059FC4}" type="datetimeFigureOut">
               <a:rPr lang="en-US" smtClean="0"/>
-              <a:t>7/18/2026</a:t>
+              <a:t>7/20/2026</a:t>
             </a:fld>
             <a:endParaRPr lang="en-US"/>
           </a:p>
@@ -849,7 +852,7 @@
           <a:p>
             <a:fld id="{5BCAD085-E8A6-8845-BD4E-CB4CCA059FC4}" type="datetimeFigureOut">
               <a:rPr lang="en-US" smtClean="0"/>
-              <a:t>7/18/2026</a:t>
+              <a:t>7/20/2026</a:t>
             </a:fld>
             <a:endParaRPr lang="en-US"/>
           </a:p>
@@ -1094,7 +1097,7 @@
           <a:p>
             <a:fld id="{5BCAD085-E8A6-8845-BD4E-CB4CCA059FC4}" type="datetimeFigureOut">
               <a:rPr lang="en-US" smtClean="0"/>
-              <a:t>7/18/2026</a:t>
+              <a:t>7/20/2026</a:t>
             </a:fld>
             <a:endParaRPr lang="en-US"/>
           </a:p>
@@ -1379,7 +1382,7 @@
           <a:p>
             <a:fld id="{5BCAD085-E8A6-8845-BD4E-CB4CCA059FC4}" type="datetimeFigureOut">
               <a:rPr lang="en-US" smtClean="0"/>
-              <a:t>7/18/2026</a:t>
+              <a:t>7/20/2026</a:t>
             </a:fld>
             <a:endParaRPr lang="en-US"/>
           </a:p>
@@ -1798,7 +1801,7 @@
           <a:p>
             <a:fld id="{5BCAD085-E8A6-8845-BD4E-CB4CCA059FC4}" type="datetimeFigureOut">
               <a:rPr lang="en-US" smtClean="0"/>
-              <a:t>7/18/2026</a:t>
+              <a:t>7/20/2026</a:t>
             </a:fld>
             <a:endParaRPr lang="en-US"/>
           </a:p>
@@ -1915,7 +1918,7 @@
           <a:p>
             <a:fld id="{5BCAD085-E8A6-8845-BD4E-CB4CCA059FC4}" type="datetimeFigureOut">
               <a:rPr lang="en-US" smtClean="0"/>
-              <a:t>7/18/2026</a:t>
+              <a:t>7/20/2026</a:t>
             </a:fld>
             <a:endParaRPr lang="en-US"/>
           </a:p>
@@ -2010,7 +2013,7 @@
           <a:p>
             <a:fld id="{5BCAD085-E8A6-8845-BD4E-CB4CCA059FC4}" type="datetimeFigureOut">
               <a:rPr lang="en-US" smtClean="0"/>
-              <a:t>7/18/2026</a:t>
+              <a:t>7/20/2026</a:t>
             </a:fld>
             <a:endParaRPr lang="en-US"/>
           </a:p>
@@ -2285,7 +2288,7 @@
           <a:p>
             <a:fld id="{5BCAD085-E8A6-8845-BD4E-CB4CCA059FC4}" type="datetimeFigureOut">
               <a:rPr lang="en-US" smtClean="0"/>
-              <a:t>7/18/2026</a:t>
+              <a:t>7/20/2026</a:t>
             </a:fld>
             <a:endParaRPr lang="en-US"/>
           </a:p>
@@ -2537,7 +2540,7 @@
           <a:p>
             <a:fld id="{5BCAD085-E8A6-8845-BD4E-CB4CCA059FC4}" type="datetimeFigureOut">
               <a:rPr lang="en-US" smtClean="0"/>
-              <a:t>7/18/2026</a:t>
+              <a:t>7/20/2026</a:t>
             </a:fld>
             <a:endParaRPr lang="en-US"/>
           </a:p>
@@ -2748,7 +2751,7 @@
           <a:p>
             <a:fld id="{5BCAD085-E8A6-8845-BD4E-CB4CCA059FC4}" type="datetimeFigureOut">
               <a:rPr lang="en-US" smtClean="0"/>
-              <a:t>7/18/2026</a:t>
+              <a:t>7/20/2026</a:t>
             </a:fld>
             <a:endParaRPr lang="en-US"/>
           </a:p>
@@ -4014,7 +4017,7 @@
         </p:nvSpPr>
         <p:spPr>
           <a:xfrm>
-            <a:off x="320040" y="960120"/>
+            <a:off x="320040" y="868680"/>
             <a:ext cx="3749039" cy="1371600"/>
           </a:xfrm>
           <a:prstGeom prst="rect">
@@ -4058,7 +4061,7 @@
         </p:nvSpPr>
         <p:spPr>
           <a:xfrm>
-            <a:off x="320040" y="960120"/>
+            <a:off x="320040" y="868680"/>
             <a:ext cx="3749039" cy="347472"/>
           </a:xfrm>
           <a:prstGeom prst="rect">
@@ -4102,7 +4105,7 @@
         </p:nvSpPr>
         <p:spPr>
           <a:xfrm>
-            <a:off x="411480" y="996696"/>
+            <a:off x="411480" y="905256"/>
             <a:ext cx="3611879" cy="292608"/>
           </a:xfrm>
           <a:prstGeom prst="rect">
@@ -4136,7 +4139,7 @@
         </p:nvSpPr>
         <p:spPr>
           <a:xfrm>
-            <a:off x="411480" y="1344168"/>
+            <a:off x="411480" y="1252728"/>
             <a:ext cx="3611879" cy="914400"/>
           </a:xfrm>
           <a:prstGeom prst="rect">
@@ -4171,7 +4174,7 @@
         </p:nvSpPr>
         <p:spPr>
           <a:xfrm>
-            <a:off x="4251959" y="960120"/>
+            <a:off x="4251959" y="868680"/>
             <a:ext cx="3749039" cy="1371600"/>
           </a:xfrm>
           <a:prstGeom prst="rect">
@@ -4215,7 +4218,7 @@
         </p:nvSpPr>
         <p:spPr>
           <a:xfrm>
-            <a:off x="4251959" y="960120"/>
+            <a:off x="4251959" y="868680"/>
             <a:ext cx="3749039" cy="347472"/>
           </a:xfrm>
           <a:prstGeom prst="rect">
@@ -4259,7 +4262,7 @@
         </p:nvSpPr>
         <p:spPr>
           <a:xfrm>
-            <a:off x="4343399" y="996696"/>
+            <a:off x="4343399" y="905256"/>
             <a:ext cx="3611879" cy="292608"/>
           </a:xfrm>
           <a:prstGeom prst="rect">
@@ -4293,7 +4296,7 @@
         </p:nvSpPr>
         <p:spPr>
           <a:xfrm>
-            <a:off x="4343399" y="1344168"/>
+            <a:off x="4343399" y="1252728"/>
             <a:ext cx="3611879" cy="914400"/>
           </a:xfrm>
           <a:prstGeom prst="rect">
@@ -4328,7 +4331,7 @@
         </p:nvSpPr>
         <p:spPr>
           <a:xfrm>
-            <a:off x="8183879" y="960120"/>
+            <a:off x="8183879" y="868680"/>
             <a:ext cx="3749039" cy="1371600"/>
           </a:xfrm>
           <a:prstGeom prst="rect">
@@ -4372,7 +4375,7 @@
         </p:nvSpPr>
         <p:spPr>
           <a:xfrm>
-            <a:off x="8183879" y="960120"/>
+            <a:off x="8183879" y="868680"/>
             <a:ext cx="3749039" cy="347472"/>
           </a:xfrm>
           <a:prstGeom prst="rect">
@@ -4416,7 +4419,7 @@
         </p:nvSpPr>
         <p:spPr>
           <a:xfrm>
-            <a:off x="8275319" y="996696"/>
+            <a:off x="8275319" y="905256"/>
             <a:ext cx="3611879" cy="292608"/>
           </a:xfrm>
           <a:prstGeom prst="rect">
@@ -4450,7 +4453,7 @@
         </p:nvSpPr>
         <p:spPr>
           <a:xfrm>
-            <a:off x="8275319" y="1344168"/>
+            <a:off x="8275319" y="1252728"/>
             <a:ext cx="3611879" cy="914400"/>
           </a:xfrm>
           <a:prstGeom prst="rect">
@@ -4485,7 +4488,7 @@
         </p:nvSpPr>
         <p:spPr>
           <a:xfrm>
-            <a:off x="320040" y="2468880"/>
+            <a:off x="320040" y="2377440"/>
             <a:ext cx="3749039" cy="1371600"/>
           </a:xfrm>
           <a:prstGeom prst="rect">
@@ -4529,7 +4532,7 @@
         </p:nvSpPr>
         <p:spPr>
           <a:xfrm>
-            <a:off x="320040" y="2468880"/>
+            <a:off x="320040" y="2377440"/>
             <a:ext cx="3749039" cy="347472"/>
           </a:xfrm>
           <a:prstGeom prst="rect">
@@ -4573,7 +4576,7 @@
         </p:nvSpPr>
         <p:spPr>
           <a:xfrm>
-            <a:off x="411480" y="2505456"/>
+            <a:off x="411480" y="2414016"/>
             <a:ext cx="3611879" cy="292608"/>
           </a:xfrm>
           <a:prstGeom prst="rect">
@@ -4607,7 +4610,7 @@
         </p:nvSpPr>
         <p:spPr>
           <a:xfrm>
-            <a:off x="411480" y="2852928"/>
+            <a:off x="411480" y="2761488"/>
             <a:ext cx="3611879" cy="914400"/>
           </a:xfrm>
           <a:prstGeom prst="rect">
@@ -4642,7 +4645,7 @@
         </p:nvSpPr>
         <p:spPr>
           <a:xfrm>
-            <a:off x="4251959" y="2468880"/>
+            <a:off x="4251959" y="2377440"/>
             <a:ext cx="3749039" cy="1371600"/>
           </a:xfrm>
           <a:prstGeom prst="rect">
@@ -4686,7 +4689,7 @@
         </p:nvSpPr>
         <p:spPr>
           <a:xfrm>
-            <a:off x="4251959" y="2468880"/>
+            <a:off x="4251959" y="2377440"/>
             <a:ext cx="3749039" cy="347472"/>
           </a:xfrm>
           <a:prstGeom prst="rect">
@@ -4730,7 +4733,7 @@
         </p:nvSpPr>
         <p:spPr>
           <a:xfrm>
-            <a:off x="4343399" y="2505456"/>
+            <a:off x="4343399" y="2414016"/>
             <a:ext cx="3611879" cy="292608"/>
           </a:xfrm>
           <a:prstGeom prst="rect">
@@ -4764,7 +4767,7 @@
         </p:nvSpPr>
         <p:spPr>
           <a:xfrm>
-            <a:off x="4343399" y="2852928"/>
+            <a:off x="4343399" y="2761488"/>
             <a:ext cx="3611879" cy="914400"/>
           </a:xfrm>
           <a:prstGeom prst="rect">
@@ -4799,7 +4802,7 @@
         </p:nvSpPr>
         <p:spPr>
           <a:xfrm>
-            <a:off x="8183879" y="2468880"/>
+            <a:off x="8183879" y="2377440"/>
             <a:ext cx="3749039" cy="1371600"/>
           </a:xfrm>
           <a:prstGeom prst="rect">
@@ -4843,7 +4846,7 @@
         </p:nvSpPr>
         <p:spPr>
           <a:xfrm>
-            <a:off x="8183879" y="2468880"/>
+            <a:off x="8183879" y="2377440"/>
             <a:ext cx="3749039" cy="347472"/>
           </a:xfrm>
           <a:prstGeom prst="rect">
@@ -4887,7 +4890,7 @@
         </p:nvSpPr>
         <p:spPr>
           <a:xfrm>
-            <a:off x="8275319" y="2505456"/>
+            <a:off x="8275319" y="2414016"/>
             <a:ext cx="3611879" cy="292608"/>
           </a:xfrm>
           <a:prstGeom prst="rect">
@@ -4921,7 +4924,7 @@
         </p:nvSpPr>
         <p:spPr>
           <a:xfrm>
-            <a:off x="8275319" y="2852928"/>
+            <a:off x="8275319" y="2761488"/>
             <a:ext cx="3611879" cy="914400"/>
           </a:xfrm>
           <a:prstGeom prst="rect">
@@ -4956,7 +4959,7 @@
         </p:nvSpPr>
         <p:spPr>
           <a:xfrm>
-            <a:off x="320040" y="3977639"/>
+            <a:off x="320040" y="3886199"/>
             <a:ext cx="3749039" cy="1371600"/>
           </a:xfrm>
           <a:prstGeom prst="rect">
@@ -5000,7 +5003,7 @@
         </p:nvSpPr>
         <p:spPr>
           <a:xfrm>
-            <a:off x="320040" y="3977639"/>
+            <a:off x="320040" y="3886199"/>
             <a:ext cx="3749039" cy="347472"/>
           </a:xfrm>
           <a:prstGeom prst="rect">
@@ -5044,7 +5047,7 @@
         </p:nvSpPr>
         <p:spPr>
           <a:xfrm>
-            <a:off x="411480" y="4014215"/>
+            <a:off x="411480" y="3922775"/>
             <a:ext cx="3611879" cy="292608"/>
           </a:xfrm>
           <a:prstGeom prst="rect">
@@ -5078,7 +5081,7 @@
         </p:nvSpPr>
         <p:spPr>
           <a:xfrm>
-            <a:off x="411480" y="4361687"/>
+            <a:off x="411480" y="4270247"/>
             <a:ext cx="3611879" cy="914400"/>
           </a:xfrm>
           <a:prstGeom prst="rect">
@@ -5113,7 +5116,7 @@
         </p:nvSpPr>
         <p:spPr>
           <a:xfrm>
-            <a:off x="4251959" y="3977639"/>
+            <a:off x="4251959" y="3886199"/>
             <a:ext cx="3749039" cy="1371600"/>
           </a:xfrm>
           <a:prstGeom prst="rect">
@@ -5157,7 +5160,7 @@
         </p:nvSpPr>
         <p:spPr>
           <a:xfrm>
-            <a:off x="4251959" y="3977639"/>
+            <a:off x="4251959" y="3886199"/>
             <a:ext cx="3749039" cy="347472"/>
           </a:xfrm>
           <a:prstGeom prst="rect">
@@ -5201,7 +5204,7 @@
         </p:nvSpPr>
         <p:spPr>
           <a:xfrm>
-            <a:off x="4343399" y="4014215"/>
+            <a:off x="4343399" y="3922775"/>
             <a:ext cx="3611879" cy="292608"/>
           </a:xfrm>
           <a:prstGeom prst="rect">
@@ -5235,7 +5238,7 @@
         </p:nvSpPr>
         <p:spPr>
           <a:xfrm>
-            <a:off x="4343399" y="4361687"/>
+            <a:off x="4343399" y="4270247"/>
             <a:ext cx="3611879" cy="914400"/>
           </a:xfrm>
           <a:prstGeom prst="rect">
@@ -5270,7 +5273,7 @@
         </p:nvSpPr>
         <p:spPr>
           <a:xfrm>
-            <a:off x="8183879" y="3977639"/>
+            <a:off x="8183879" y="3886199"/>
             <a:ext cx="3749039" cy="1371600"/>
           </a:xfrm>
           <a:prstGeom prst="rect">
@@ -5314,7 +5317,7 @@
         </p:nvSpPr>
         <p:spPr>
           <a:xfrm>
-            <a:off x="8183879" y="3977639"/>
+            <a:off x="8183879" y="3886199"/>
             <a:ext cx="3749039" cy="347472"/>
           </a:xfrm>
           <a:prstGeom prst="rect">
@@ -5358,7 +5361,7 @@
         </p:nvSpPr>
         <p:spPr>
           <a:xfrm>
-            <a:off x="8275319" y="4014215"/>
+            <a:off x="8275319" y="3922775"/>
             <a:ext cx="3611879" cy="292608"/>
           </a:xfrm>
           <a:prstGeom prst="rect">
@@ -5392,7 +5395,7 @@
         </p:nvSpPr>
         <p:spPr>
           <a:xfrm>
-            <a:off x="8275319" y="4361687"/>
+            <a:off x="8275319" y="4270247"/>
             <a:ext cx="3611879" cy="914400"/>
           </a:xfrm>
           <a:prstGeom prst="rect">
@@ -5427,7 +5430,7 @@
         </p:nvSpPr>
         <p:spPr>
           <a:xfrm>
-            <a:off x="320040" y="5486399"/>
+            <a:off x="320040" y="5394959"/>
             <a:ext cx="3749039" cy="1371600"/>
           </a:xfrm>
           <a:prstGeom prst="rect">
@@ -5471,7 +5474,7 @@
         </p:nvSpPr>
         <p:spPr>
           <a:xfrm>
-            <a:off x="320040" y="5486399"/>
+            <a:off x="320040" y="5394959"/>
             <a:ext cx="3749039" cy="347472"/>
           </a:xfrm>
           <a:prstGeom prst="rect">
@@ -5515,7 +5518,7 @@
         </p:nvSpPr>
         <p:spPr>
           <a:xfrm>
-            <a:off x="411480" y="5522975"/>
+            <a:off x="411480" y="5431535"/>
             <a:ext cx="3611879" cy="292608"/>
           </a:xfrm>
           <a:prstGeom prst="rect">
@@ -5549,7 +5552,7 @@
         </p:nvSpPr>
         <p:spPr>
           <a:xfrm>
-            <a:off x="411480" y="5870447"/>
+            <a:off x="411480" y="5779007"/>
             <a:ext cx="3611879" cy="914400"/>
           </a:xfrm>
           <a:prstGeom prst="rect">
@@ -13530,7 +13533,7 @@
         </p:nvSpPr>
         <p:spPr>
           <a:xfrm>
-            <a:off x="0" y="73152"/>
+            <a:off x="0" y="155448"/>
             <a:ext cx="12188952" cy="45720"/>
           </a:xfrm>
           <a:prstGeom prst="rect">
@@ -13574,7 +13577,7 @@
         </p:nvSpPr>
         <p:spPr>
           <a:xfrm>
-            <a:off x="457200" y="274320"/>
+            <a:off x="457200" y="841248"/>
             <a:ext cx="10972800" cy="548640"/>
           </a:xfrm>
           <a:prstGeom prst="rect">
@@ -13590,7 +13593,7 @@
           <a:p>
             <a:pPr algn="l"/>
             <a:r>
-              <a:rPr sz="2200" b="1">
+              <a:rPr sz="2200" b="1" dirty="0">
                 <a:solidFill>
                   <a:srgbClr val="FFFFFF"/>
                 </a:solidFill>
@@ -13608,7 +13611,7 @@
         </p:nvSpPr>
         <p:spPr>
           <a:xfrm>
-            <a:off x="457200" y="914400"/>
+            <a:off x="457200" y="1344168"/>
             <a:ext cx="5486400" cy="365760"/>
           </a:xfrm>
           <a:prstGeom prst="rect">
@@ -13642,7 +13645,7 @@
         </p:nvSpPr>
         <p:spPr>
           <a:xfrm>
-            <a:off x="457200" y="1362456"/>
+            <a:off x="457200" y="1792224"/>
             <a:ext cx="292608" cy="292608"/>
           </a:xfrm>
           <a:prstGeom prst="rect">
@@ -13686,7 +13689,7 @@
         </p:nvSpPr>
         <p:spPr>
           <a:xfrm>
-            <a:off x="457200" y="1362456"/>
+            <a:off x="457200" y="1792224"/>
             <a:ext cx="292608" cy="292608"/>
           </a:xfrm>
           <a:prstGeom prst="rect">
@@ -13720,7 +13723,7 @@
         </p:nvSpPr>
         <p:spPr>
           <a:xfrm>
-            <a:off x="841248" y="1362456"/>
+            <a:off x="841248" y="1792224"/>
             <a:ext cx="2286000" cy="292608"/>
           </a:xfrm>
           <a:prstGeom prst="rect">
@@ -13754,7 +13757,7 @@
         </p:nvSpPr>
         <p:spPr>
           <a:xfrm>
-            <a:off x="3200400" y="1325880"/>
+            <a:off x="3200400" y="1755648"/>
             <a:ext cx="8412480" cy="566928"/>
           </a:xfrm>
           <a:prstGeom prst="rect">
@@ -13788,7 +13791,7 @@
         </p:nvSpPr>
         <p:spPr>
           <a:xfrm>
-            <a:off x="457200" y="2020824"/>
+            <a:off x="457200" y="2450592"/>
             <a:ext cx="292608" cy="292608"/>
           </a:xfrm>
           <a:prstGeom prst="rect">
@@ -13832,7 +13835,7 @@
         </p:nvSpPr>
         <p:spPr>
           <a:xfrm>
-            <a:off x="457200" y="2020824"/>
+            <a:off x="457200" y="2450592"/>
             <a:ext cx="292608" cy="292608"/>
           </a:xfrm>
           <a:prstGeom prst="rect">
@@ -13866,7 +13869,7 @@
         </p:nvSpPr>
         <p:spPr>
           <a:xfrm>
-            <a:off x="841248" y="2020824"/>
+            <a:off x="841248" y="2450592"/>
             <a:ext cx="2286000" cy="292608"/>
           </a:xfrm>
           <a:prstGeom prst="rect">
@@ -13900,7 +13903,7 @@
         </p:nvSpPr>
         <p:spPr>
           <a:xfrm>
-            <a:off x="3200400" y="1984248"/>
+            <a:off x="3200400" y="2414016"/>
             <a:ext cx="8412480" cy="566928"/>
           </a:xfrm>
           <a:prstGeom prst="rect">
@@ -13934,7 +13937,7 @@
         </p:nvSpPr>
         <p:spPr>
           <a:xfrm>
-            <a:off x="457200" y="2679191"/>
+            <a:off x="457200" y="3108959"/>
             <a:ext cx="292608" cy="292608"/>
           </a:xfrm>
           <a:prstGeom prst="rect">
@@ -13978,7 +13981,7 @@
         </p:nvSpPr>
         <p:spPr>
           <a:xfrm>
-            <a:off x="457200" y="2679191"/>
+            <a:off x="457200" y="3108959"/>
             <a:ext cx="292608" cy="292608"/>
           </a:xfrm>
           <a:prstGeom prst="rect">
@@ -14012,7 +14015,7 @@
         </p:nvSpPr>
         <p:spPr>
           <a:xfrm>
-            <a:off x="841248" y="2679191"/>
+            <a:off x="841248" y="3108959"/>
             <a:ext cx="2286000" cy="292608"/>
           </a:xfrm>
           <a:prstGeom prst="rect">
@@ -14046,7 +14049,7 @@
         </p:nvSpPr>
         <p:spPr>
           <a:xfrm>
-            <a:off x="3200400" y="2642615"/>
+            <a:off x="3200400" y="3072383"/>
             <a:ext cx="8412480" cy="566928"/>
           </a:xfrm>
           <a:prstGeom prst="rect">
@@ -14081,7 +14084,7 @@
         </p:nvSpPr>
         <p:spPr>
           <a:xfrm>
-            <a:off x="457200" y="3337560"/>
+            <a:off x="457200" y="3767328"/>
             <a:ext cx="292608" cy="292608"/>
           </a:xfrm>
           <a:prstGeom prst="rect">
@@ -14125,7 +14128,7 @@
         </p:nvSpPr>
         <p:spPr>
           <a:xfrm>
-            <a:off x="457200" y="3337560"/>
+            <a:off x="457200" y="3767328"/>
             <a:ext cx="292608" cy="292608"/>
           </a:xfrm>
           <a:prstGeom prst="rect">
@@ -14159,7 +14162,7 @@
         </p:nvSpPr>
         <p:spPr>
           <a:xfrm>
-            <a:off x="841248" y="3337560"/>
+            <a:off x="841248" y="3767328"/>
             <a:ext cx="2286000" cy="292608"/>
           </a:xfrm>
           <a:prstGeom prst="rect">
@@ -14193,7 +14196,7 @@
         </p:nvSpPr>
         <p:spPr>
           <a:xfrm>
-            <a:off x="3200400" y="3300984"/>
+            <a:off x="3200400" y="3730752"/>
             <a:ext cx="8412480" cy="566928"/>
           </a:xfrm>
           <a:prstGeom prst="rect">
@@ -14228,7 +14231,7 @@
         </p:nvSpPr>
         <p:spPr>
           <a:xfrm>
-            <a:off x="457200" y="3657600"/>
+            <a:off x="457200" y="4087368"/>
             <a:ext cx="5486400" cy="365760"/>
           </a:xfrm>
           <a:prstGeom prst="rect">
@@ -14262,7 +14265,7 @@
         </p:nvSpPr>
         <p:spPr>
           <a:xfrm>
-            <a:off x="320040" y="4114800"/>
+            <a:off x="320040" y="4544568"/>
             <a:ext cx="11521440" cy="384048"/>
           </a:xfrm>
           <a:prstGeom prst="rect">
@@ -14306,7 +14309,7 @@
         </p:nvSpPr>
         <p:spPr>
           <a:xfrm>
-            <a:off x="457200" y="4160520"/>
+            <a:off x="457200" y="4590288"/>
             <a:ext cx="640080" cy="310896"/>
           </a:xfrm>
           <a:prstGeom prst="rect">
@@ -14340,7 +14343,7 @@
         </p:nvSpPr>
         <p:spPr>
           <a:xfrm>
-            <a:off x="1188720" y="4160520"/>
+            <a:off x="1188720" y="4590288"/>
             <a:ext cx="5029200" cy="310896"/>
           </a:xfrm>
           <a:prstGeom prst="rect">
@@ -14374,7 +14377,7 @@
         </p:nvSpPr>
         <p:spPr>
           <a:xfrm>
-            <a:off x="6400800" y="4160520"/>
+            <a:off x="6400800" y="4590288"/>
             <a:ext cx="5303520" cy="310896"/>
           </a:xfrm>
           <a:prstGeom prst="rect">
@@ -14408,7 +14411,7 @@
         </p:nvSpPr>
         <p:spPr>
           <a:xfrm>
-            <a:off x="320040" y="0"/>
+            <a:off x="320040" y="429768"/>
             <a:ext cx="11521440" cy="384048"/>
           </a:xfrm>
           <a:prstGeom prst="rect">
@@ -14452,7 +14455,7 @@
         </p:nvSpPr>
         <p:spPr>
           <a:xfrm>
-            <a:off x="457200" y="0"/>
+            <a:off x="457200" y="429768"/>
             <a:ext cx="640080" cy="310896"/>
           </a:xfrm>
           <a:prstGeom prst="rect">
@@ -14486,7 +14489,7 @@
         </p:nvSpPr>
         <p:spPr>
           <a:xfrm>
-            <a:off x="1188720" y="0"/>
+            <a:off x="1188720" y="429768"/>
             <a:ext cx="5029200" cy="310896"/>
           </a:xfrm>
           <a:prstGeom prst="rect">
@@ -14520,7 +14523,7 @@
         </p:nvSpPr>
         <p:spPr>
           <a:xfrm>
-            <a:off x="6400800" y="0"/>
+            <a:off x="6400800" y="429768"/>
             <a:ext cx="5303520" cy="310896"/>
           </a:xfrm>
           <a:prstGeom prst="rect">
@@ -14554,7 +14557,7 @@
         </p:nvSpPr>
         <p:spPr>
           <a:xfrm>
-            <a:off x="320040" y="0"/>
+            <a:off x="320040" y="429768"/>
             <a:ext cx="11521440" cy="384048"/>
           </a:xfrm>
           <a:prstGeom prst="rect">
@@ -14598,7 +14601,7 @@
         </p:nvSpPr>
         <p:spPr>
           <a:xfrm>
-            <a:off x="457200" y="0"/>
+            <a:off x="457200" y="429768"/>
             <a:ext cx="640080" cy="310896"/>
           </a:xfrm>
           <a:prstGeom prst="rect">
@@ -14632,7 +14635,7 @@
         </p:nvSpPr>
         <p:spPr>
           <a:xfrm>
-            <a:off x="1188720" y="0"/>
+            <a:off x="1188720" y="429768"/>
             <a:ext cx="5029200" cy="310896"/>
           </a:xfrm>
           <a:prstGeom prst="rect">
@@ -14666,7 +14669,7 @@
         </p:nvSpPr>
         <p:spPr>
           <a:xfrm>
-            <a:off x="6400800" y="0"/>
+            <a:off x="6400800" y="429768"/>
             <a:ext cx="5303520" cy="310896"/>
           </a:xfrm>
           <a:prstGeom prst="rect">
@@ -14700,7 +14703,7 @@
         </p:nvSpPr>
         <p:spPr>
           <a:xfrm>
-            <a:off x="320040" y="0"/>
+            <a:off x="320040" y="429768"/>
             <a:ext cx="11521440" cy="384048"/>
           </a:xfrm>
           <a:prstGeom prst="rect">
@@ -14744,7 +14747,7 @@
         </p:nvSpPr>
         <p:spPr>
           <a:xfrm>
-            <a:off x="457200" y="0"/>
+            <a:off x="457200" y="429768"/>
             <a:ext cx="640080" cy="310896"/>
           </a:xfrm>
           <a:prstGeom prst="rect">
@@ -14778,7 +14781,7 @@
         </p:nvSpPr>
         <p:spPr>
           <a:xfrm>
-            <a:off x="1188720" y="0"/>
+            <a:off x="1188720" y="429768"/>
             <a:ext cx="5029200" cy="310896"/>
           </a:xfrm>
           <a:prstGeom prst="rect">
@@ -14812,7 +14815,7 @@
         </p:nvSpPr>
         <p:spPr>
           <a:xfrm>
-            <a:off x="6400800" y="0"/>
+            <a:off x="6400800" y="429768"/>
             <a:ext cx="5303520" cy="310896"/>
           </a:xfrm>
           <a:prstGeom prst="rect">
@@ -14846,7 +14849,7 @@
         </p:nvSpPr>
         <p:spPr>
           <a:xfrm>
-            <a:off x="320040" y="0"/>
+            <a:off x="320040" y="429768"/>
             <a:ext cx="11521440" cy="384048"/>
           </a:xfrm>
           <a:prstGeom prst="rect">
@@ -14890,7 +14893,7 @@
         </p:nvSpPr>
         <p:spPr>
           <a:xfrm>
-            <a:off x="457200" y="0"/>
+            <a:off x="457200" y="429768"/>
             <a:ext cx="640080" cy="310896"/>
           </a:xfrm>
           <a:prstGeom prst="rect">
@@ -14924,7 +14927,7 @@
         </p:nvSpPr>
         <p:spPr>
           <a:xfrm>
-            <a:off x="1188720" y="0"/>
+            <a:off x="1188720" y="429768"/>
             <a:ext cx="5029200" cy="310896"/>
           </a:xfrm>
           <a:prstGeom prst="rect">
@@ -14958,7 +14961,7 @@
         </p:nvSpPr>
         <p:spPr>
           <a:xfrm>
-            <a:off x="6400800" y="0"/>
+            <a:off x="6400800" y="429768"/>
             <a:ext cx="5303520" cy="310896"/>
           </a:xfrm>
           <a:prstGeom prst="rect">
@@ -14992,7 +14995,7 @@
         </p:nvSpPr>
         <p:spPr>
           <a:xfrm>
-            <a:off x="320040" y="0"/>
+            <a:off x="320040" y="429768"/>
             <a:ext cx="11521440" cy="384048"/>
           </a:xfrm>
           <a:prstGeom prst="rect">
@@ -15036,7 +15039,7 @@
         </p:nvSpPr>
         <p:spPr>
           <a:xfrm>
-            <a:off x="457200" y="0"/>
+            <a:off x="457200" y="429768"/>
             <a:ext cx="640080" cy="310896"/>
           </a:xfrm>
           <a:prstGeom prst="rect">
@@ -15070,7 +15073,7 @@
         </p:nvSpPr>
         <p:spPr>
           <a:xfrm>
-            <a:off x="1188720" y="0"/>
+            <a:off x="1188720" y="429768"/>
             <a:ext cx="5029200" cy="310896"/>
           </a:xfrm>
           <a:prstGeom prst="rect">
@@ -15104,7 +15107,7 @@
         </p:nvSpPr>
         <p:spPr>
           <a:xfrm>
-            <a:off x="6400800" y="0"/>
+            <a:off x="6400800" y="429768"/>
             <a:ext cx="5303520" cy="310896"/>
           </a:xfrm>
           <a:prstGeom prst="rect">
@@ -15138,7 +15141,7 @@
         </p:nvSpPr>
         <p:spPr>
           <a:xfrm>
-            <a:off x="320040" y="0"/>
+            <a:off x="320040" y="429768"/>
             <a:ext cx="11521440" cy="384048"/>
           </a:xfrm>
           <a:prstGeom prst="rect">
@@ -15182,7 +15185,7 @@
         </p:nvSpPr>
         <p:spPr>
           <a:xfrm>
-            <a:off x="457200" y="0"/>
+            <a:off x="457200" y="429768"/>
             <a:ext cx="640080" cy="310896"/>
           </a:xfrm>
           <a:prstGeom prst="rect">
@@ -15216,7 +15219,7 @@
         </p:nvSpPr>
         <p:spPr>
           <a:xfrm>
-            <a:off x="1188720" y="0"/>
+            <a:off x="1188720" y="429768"/>
             <a:ext cx="5029200" cy="310896"/>
           </a:xfrm>
           <a:prstGeom prst="rect">
@@ -15250,7 +15253,7 @@
         </p:nvSpPr>
         <p:spPr>
           <a:xfrm>
-            <a:off x="6400800" y="0"/>
+            <a:off x="6400800" y="429768"/>
             <a:ext cx="5303520" cy="310896"/>
           </a:xfrm>
           <a:prstGeom prst="rect">
@@ -17054,7 +17057,7 @@
         </p:nvSpPr>
         <p:spPr>
           <a:xfrm>
-            <a:off x="2377440" y="1325880"/>
+            <a:off x="2331720" y="1266444"/>
             <a:ext cx="457200" cy="365760"/>
           </a:xfrm>
           <a:prstGeom prst="rect">
@@ -17070,7 +17073,7 @@
           <a:p>
             <a:pPr algn="l"/>
             <a:r>
-              <a:rPr sz="2200" b="1">
+              <a:rPr sz="2200" b="1" dirty="0">
                 <a:solidFill>
                   <a:srgbClr val="606EF5"/>
                 </a:solidFill>
@@ -17166,7 +17169,7 @@
         </p:nvSpPr>
         <p:spPr>
           <a:xfrm>
-            <a:off x="4663440" y="1325880"/>
+            <a:off x="4617720" y="1266444"/>
             <a:ext cx="457200" cy="365760"/>
           </a:xfrm>
           <a:prstGeom prst="rect">
@@ -17182,7 +17185,7 @@
           <a:p>
             <a:pPr algn="l"/>
             <a:r>
-              <a:rPr sz="2200" b="1">
+              <a:rPr sz="2200" b="1" dirty="0">
                 <a:solidFill>
                   <a:srgbClr val="606EF5"/>
                 </a:solidFill>
@@ -17279,7 +17282,7 @@
         </p:nvSpPr>
         <p:spPr>
           <a:xfrm>
-            <a:off x="6949440" y="1325880"/>
+            <a:off x="6885306" y="1266444"/>
             <a:ext cx="457200" cy="365760"/>
           </a:xfrm>
           <a:prstGeom prst="rect">
@@ -17295,7 +17298,7 @@
           <a:p>
             <a:pPr algn="l"/>
             <a:r>
-              <a:rPr sz="2200" b="1">
+              <a:rPr sz="2200" b="1" dirty="0">
                 <a:solidFill>
                   <a:srgbClr val="606EF5"/>
                 </a:solidFill>
@@ -17392,7 +17395,7 @@
         </p:nvSpPr>
         <p:spPr>
           <a:xfrm>
-            <a:off x="9235440" y="1325880"/>
+            <a:off x="9180576" y="1280160"/>
             <a:ext cx="457200" cy="365760"/>
           </a:xfrm>
           <a:prstGeom prst="rect">
@@ -17408,7 +17411,7 @@
           <a:p>
             <a:pPr algn="l"/>
             <a:r>
-              <a:rPr sz="2200" b="1">
+              <a:rPr sz="2200" b="1" dirty="0">
                 <a:solidFill>
                   <a:srgbClr val="606EF5"/>
                 </a:solidFill>
@@ -27922,7 +27925,7 @@
 </file>
 
 <file path=ppt/slides/slide26.xml><?xml version="1.0" encoding="utf-8"?>
-<p:sld xmlns:a="http://schemas.openxmlformats.org/drawingml/2006/main" xmlns:p="http://schemas.openxmlformats.org/presentationml/2006/main" xmlns:r="http://schemas.openxmlformats.org/officeDocument/2006/relationships">
+<p:sld xmlns:a="http://schemas.openxmlformats.org/drawingml/2006/main" xmlns:r="http://schemas.openxmlformats.org/officeDocument/2006/relationships" xmlns:p="http://schemas.openxmlformats.org/presentationml/2006/main">
   <p:cSld>
     <p:spTree>
       <p:nvGrpSpPr>
@@ -27930,7 +27933,14 @@
         <p:cNvGrpSpPr/>
         <p:nvPr/>
       </p:nvGrpSpPr>
-      <p:grpSpPr/>
+      <p:grpSpPr>
+        <a:xfrm>
+          <a:off x="0" y="0"/>
+          <a:ext cx="0" cy="0"/>
+          <a:chOff x="0" y="0"/>
+          <a:chExt cx="0" cy="0"/>
+        </a:xfrm>
+      </p:grpSpPr>
       <p:sp>
         <p:nvSpPr>
           <p:cNvPr id="2" name="Rectangle 1"/>
@@ -28690,7 +28700,7 @@
 </file>
 
 <file path=ppt/slides/slide27.xml><?xml version="1.0" encoding="utf-8"?>
-<p:sld xmlns:a="http://schemas.openxmlformats.org/drawingml/2006/main" xmlns:p="http://schemas.openxmlformats.org/presentationml/2006/main" xmlns:r="http://schemas.openxmlformats.org/officeDocument/2006/relationships">
+<p:sld xmlns:a="http://schemas.openxmlformats.org/drawingml/2006/main" xmlns:r="http://schemas.openxmlformats.org/officeDocument/2006/relationships" xmlns:p="http://schemas.openxmlformats.org/presentationml/2006/main">
   <p:cSld>
     <p:spTree>
       <p:nvGrpSpPr>
@@ -28698,7 +28708,14 @@
         <p:cNvGrpSpPr/>
         <p:nvPr/>
       </p:nvGrpSpPr>
-      <p:grpSpPr/>
+      <p:grpSpPr>
+        <a:xfrm>
+          <a:off x="0" y="0"/>
+          <a:ext cx="0" cy="0"/>
+          <a:chOff x="0" y="0"/>
+          <a:chExt cx="0" cy="0"/>
+        </a:xfrm>
+      </p:grpSpPr>
       <p:sp>
         <p:nvSpPr>
           <p:cNvPr id="2" name="Rectangle 1"/>
@@ -29944,7 +29961,7 @@
 </file>
 
 <file path=ppt/slides/slide28.xml><?xml version="1.0" encoding="utf-8"?>
-<p:sld xmlns:a="http://schemas.openxmlformats.org/drawingml/2006/main" xmlns:p="http://schemas.openxmlformats.org/presentationml/2006/main" xmlns:r="http://schemas.openxmlformats.org/officeDocument/2006/relationships">
+<p:sld xmlns:a="http://schemas.openxmlformats.org/drawingml/2006/main" xmlns:r="http://schemas.openxmlformats.org/officeDocument/2006/relationships" xmlns:p="http://schemas.openxmlformats.org/presentationml/2006/main">
   <p:cSld>
     <p:spTree>
       <p:nvGrpSpPr>
@@ -29952,7 +29969,14 @@
         <p:cNvGrpSpPr/>
         <p:nvPr/>
       </p:nvGrpSpPr>
-      <p:grpSpPr/>
+      <p:grpSpPr>
+        <a:xfrm>
+          <a:off x="0" y="0"/>
+          <a:ext cx="0" cy="0"/>
+          <a:chOff x="0" y="0"/>
+          <a:chExt cx="0" cy="0"/>
+        </a:xfrm>
+      </p:grpSpPr>
       <p:sp>
         <p:nvSpPr>
           <p:cNvPr id="2" name="Rectangle 1"/>
@@ -30737,7 +30761,7 @@
         <p:spPr>
           <a:xfrm>
             <a:off x="0" y="0"/>
-            <a:ext cx="12188952" cy="6858000"/>
+            <a:ext cx="12188825" cy="6858000"/>
           </a:xfrm>
           <a:prstGeom prst="rect">
             <a:avLst/>
@@ -30748,6 +30772,7 @@
           <a:ln>
             <a:noFill/>
           </a:ln>
+          <a:effectLst/>
         </p:spPr>
         <p:style>
           <a:lnRef idx="1">
@@ -30780,8 +30805,8 @@
         </p:nvSpPr>
         <p:spPr>
           <a:xfrm>
-            <a:off x="0" y="0"/>
-            <a:ext cx="12188952" cy="45720"/>
+            <a:off x="0" y="73152"/>
+            <a:ext cx="12188825" cy="45720"/>
           </a:xfrm>
           <a:prstGeom prst="rect">
             <a:avLst/>
@@ -30792,6 +30817,7 @@
           <a:ln>
             <a:noFill/>
           </a:ln>
+          <a:effectLst/>
         </p:spPr>
         <p:style>
           <a:lnRef idx="1">
@@ -30818,516 +30844,177 @@
       </p:sp>
       <p:sp>
         <p:nvSpPr>
-          <p:cNvPr id="4" name="Rectangle 3"/>
-          <p:cNvSpPr/>
-          <p:nvPr/>
-        </p:nvSpPr>
-        <p:spPr>
-          <a:xfrm>
-            <a:off x="0" y="1371600"/>
-            <a:ext cx="12188952" cy="4114800"/>
-          </a:xfrm>
-          <a:prstGeom prst="rect">
-            <a:avLst/>
-          </a:prstGeom>
-          <a:solidFill>
-            <a:srgbClr val="1A243E"/>
-          </a:solidFill>
-          <a:ln>
-            <a:noFill/>
+          <p:cNvPr id="4" name="TextBox 3"/>
+          <p:cNvSpPr txBox="1"/>
+          <p:nvPr/>
+        </p:nvSpPr>
+        <p:spPr>
+          <a:xfrm>
+            <a:off x="457200" y="274320"/>
+            <a:ext cx="10972800" cy="548640"/>
+          </a:xfrm>
+          <a:prstGeom prst="rect">
+            <a:avLst/>
+          </a:prstGeom>
+          <a:noFill/>
+        </p:spPr>
+        <p:txBody>
+          <a:bodyPr wrap="square">
+            <a:spAutoFit/>
+          </a:bodyPr>
+          <a:lstStyle/>
+          <a:p>
+            <a:r>
+              <a:rPr sz="2600" b="1">
+                <a:solidFill>
+                  <a:srgbClr val="FFFFFF"/>
+                </a:solidFill>
+              </a:rPr>
+              <a:t>How To Use: Visual Builder — Templates &amp; Auto-Build</a:t>
+            </a:r>
+          </a:p>
+        </p:txBody>
+      </p:sp>
+      <p:sp>
+        <p:nvSpPr>
+          <p:cNvPr id="5" name="TextBox 4"/>
+          <p:cNvSpPr txBox="1"/>
+          <p:nvPr/>
+        </p:nvSpPr>
+        <p:spPr>
+          <a:xfrm>
+            <a:off x="11731752" y="6492240"/>
+            <a:ext cx="457200" cy="320040"/>
+          </a:xfrm>
+          <a:prstGeom prst="rect">
+            <a:avLst/>
+          </a:prstGeom>
+          <a:noFill/>
+        </p:spPr>
+        <p:txBody>
+          <a:bodyPr wrap="none">
+            <a:spAutoFit/>
+          </a:bodyPr>
+          <a:lstStyle/>
+          <a:p>
+            <a:r>
+              <a:rPr sz="1100">
+                <a:solidFill>
+                  <a:srgbClr val="CBD5E1"/>
+                </a:solidFill>
+              </a:rPr>
+              <a:t>29</a:t>
+            </a:r>
+          </a:p>
+        </p:txBody>
+      </p:sp>
+      <p:pic>
+        <p:nvPicPr>
+          <p:cNvPr id="6" name="Picture 5" descr="02_builder_templates.png"/>
+          <p:cNvPicPr>
+            <a:picLocks noChangeAspect="1"/>
+          </p:cNvPicPr>
+          <p:nvPr/>
+        </p:nvPicPr>
+        <p:blipFill>
+          <a:blip r:embed="rId2"/>
+          <a:stretch>
+            <a:fillRect/>
+          </a:stretch>
+        </p:blipFill>
+        <p:spPr>
+          <a:xfrm>
+            <a:off x="457200" y="1051560"/>
+            <a:ext cx="5486400" cy="3086100"/>
+          </a:xfrm>
+          <a:prstGeom prst="rect">
+            <a:avLst/>
+          </a:prstGeom>
+          <a:ln w="12700">
+            <a:solidFill>
+              <a:srgbClr val="334155"/>
+            </a:solidFill>
           </a:ln>
         </p:spPr>
-        <p:style>
-          <a:lnRef idx="1">
-            <a:schemeClr val="accent1"/>
-          </a:lnRef>
-          <a:fillRef idx="3">
-            <a:schemeClr val="accent1"/>
-          </a:fillRef>
-          <a:effectRef idx="2">
-            <a:schemeClr val="accent1"/>
-          </a:effectRef>
-          <a:fontRef idx="minor">
-            <a:schemeClr val="lt1"/>
-          </a:fontRef>
-        </p:style>
-        <p:txBody>
-          <a:bodyPr rtlCol="0" anchor="ctr"/>
-          <a:lstStyle/>
-          <a:p>
-            <a:pPr algn="ctr"/>
-            <a:endParaRPr/>
-          </a:p>
-        </p:txBody>
-      </p:sp>
-      <p:sp>
-        <p:nvSpPr>
-          <p:cNvPr id="5" name="TextBox 4"/>
-          <p:cNvSpPr txBox="1"/>
-          <p:nvPr/>
-        </p:nvSpPr>
-        <p:spPr>
-          <a:xfrm>
-            <a:off x="457200" y="1645920"/>
-            <a:ext cx="10972800" cy="914400"/>
-          </a:xfrm>
-          <a:prstGeom prst="rect">
-            <a:avLst/>
-          </a:prstGeom>
-          <a:noFill/>
-        </p:spPr>
-        <p:txBody>
-          <a:bodyPr wrap="square">
-            <a:spAutoFit/>
-          </a:bodyPr>
-          <a:lstStyle/>
-          <a:p>
-            <a:pPr algn="ctr"/>
-            <a:r>
-              <a:rPr sz="5400" b="1">
-                <a:solidFill>
-                  <a:srgbClr val="FFFFFF"/>
-                </a:solidFill>
-              </a:rPr>
-              <a:t>AgentForge</a:t>
-            </a:r>
-          </a:p>
-        </p:txBody>
-      </p:sp>
-      <p:sp>
-        <p:nvSpPr>
-          <p:cNvPr id="6" name="TextBox 5"/>
-          <p:cNvSpPr txBox="1"/>
-          <p:nvPr/>
-        </p:nvSpPr>
-        <p:spPr>
-          <a:xfrm>
-            <a:off x="457200" y="2606040"/>
-            <a:ext cx="10972800" cy="731520"/>
-          </a:xfrm>
-          <a:prstGeom prst="rect">
-            <a:avLst/>
-          </a:prstGeom>
-          <a:noFill/>
-        </p:spPr>
-        <p:txBody>
-          <a:bodyPr wrap="square">
-            <a:spAutoFit/>
-          </a:bodyPr>
-          <a:lstStyle/>
-          <a:p>
-            <a:pPr algn="ctr"/>
-            <a:r>
-              <a:rPr sz="2200" b="0">
+      </p:pic>
+      <p:pic>
+        <p:nvPicPr>
+          <p:cNvPr id="7" name="Picture 6" descr="03_builder_autobuild.png"/>
+          <p:cNvPicPr>
+            <a:picLocks noChangeAspect="1"/>
+          </p:cNvPicPr>
+          <p:nvPr/>
+        </p:nvPicPr>
+        <p:blipFill>
+          <a:blip r:embed="rId3"/>
+          <a:stretch>
+            <a:fillRect/>
+          </a:stretch>
+        </p:blipFill>
+        <p:spPr>
+          <a:xfrm>
+            <a:off x="6172200" y="1051560"/>
+            <a:ext cx="5486400" cy="3086100"/>
+          </a:xfrm>
+          <a:prstGeom prst="rect">
+            <a:avLst/>
+          </a:prstGeom>
+          <a:ln w="12700">
+            <a:solidFill>
+              <a:srgbClr val="334155"/>
+            </a:solidFill>
+          </a:ln>
+        </p:spPr>
+      </p:pic>
+      <p:sp>
+        <p:nvSpPr>
+          <p:cNvPr id="8" name="TextBox 7"/>
+          <p:cNvSpPr txBox="1"/>
+          <p:nvPr/>
+        </p:nvSpPr>
+        <p:spPr>
+          <a:xfrm>
+            <a:off x="457200" y="5440680"/>
+            <a:ext cx="11247120" cy="1188720"/>
+          </a:xfrm>
+          <a:prstGeom prst="rect">
+            <a:avLst/>
+          </a:prstGeom>
+          <a:noFill/>
+        </p:spPr>
+        <p:txBody>
+          <a:bodyPr wrap="square">
+            <a:spAutoFit/>
+          </a:bodyPr>
+          <a:lstStyle/>
+          <a:p>
+            <a:pPr>
+              <a:spcAft>
+                <a:spcPts val="400"/>
+              </a:spcAft>
+            </a:pPr>
+            <a:r>
+              <a:rPr sz="1100">
                 <a:solidFill>
                   <a:srgbClr val="CBD5E1"/>
                 </a:solidFill>
               </a:rPr>
-              <a:t>Build the next generation of enterprise AI agents — today.</a:t>
-            </a:r>
-          </a:p>
-        </p:txBody>
-      </p:sp>
-      <p:sp>
-        <p:nvSpPr>
-          <p:cNvPr id="7" name="Rectangle 6"/>
-          <p:cNvSpPr/>
-          <p:nvPr/>
-        </p:nvSpPr>
-        <p:spPr>
-          <a:xfrm>
-            <a:off x="1371600" y="3657600"/>
-            <a:ext cx="2834640" cy="777240"/>
-          </a:xfrm>
-          <a:prstGeom prst="rect">
-            <a:avLst/>
-          </a:prstGeom>
-          <a:solidFill>
-            <a:srgbClr val="606EF5"/>
-          </a:solidFill>
-          <a:ln>
-            <a:noFill/>
-          </a:ln>
-        </p:spPr>
-        <p:style>
-          <a:lnRef idx="1">
-            <a:schemeClr val="accent1"/>
-          </a:lnRef>
-          <a:fillRef idx="3">
-            <a:schemeClr val="accent1"/>
-          </a:fillRef>
-          <a:effectRef idx="2">
-            <a:schemeClr val="accent1"/>
-          </a:effectRef>
-          <a:fontRef idx="minor">
-            <a:schemeClr val="lt1"/>
-          </a:fontRef>
-        </p:style>
-        <p:txBody>
-          <a:bodyPr rtlCol="0" anchor="ctr"/>
-          <a:lstStyle/>
-          <a:p>
-            <a:pPr algn="ctr"/>
-            <a:endParaRPr/>
-          </a:p>
-        </p:txBody>
-      </p:sp>
-      <p:sp>
-        <p:nvSpPr>
-          <p:cNvPr id="8" name="TextBox 7"/>
-          <p:cNvSpPr txBox="1"/>
-          <p:nvPr/>
-        </p:nvSpPr>
-        <p:spPr>
-          <a:xfrm>
-            <a:off x="1371600" y="3703320"/>
-            <a:ext cx="2834640" cy="384048"/>
-          </a:xfrm>
-          <a:prstGeom prst="rect">
-            <a:avLst/>
-          </a:prstGeom>
-          <a:noFill/>
-        </p:spPr>
-        <p:txBody>
-          <a:bodyPr wrap="square">
-            <a:spAutoFit/>
-          </a:bodyPr>
-          <a:lstStyle/>
-          <a:p>
-            <a:pPr algn="ctr"/>
-            <a:r>
-              <a:rPr sz="1400" b="1">
-                <a:solidFill>
-                  <a:srgbClr val="FFFFFF"/>
-                </a:solidFill>
-              </a:rPr>
-              <a:t>🚀  Start Building</a:t>
-            </a:r>
-          </a:p>
-        </p:txBody>
-      </p:sp>
-      <p:sp>
-        <p:nvSpPr>
-          <p:cNvPr id="9" name="TextBox 8"/>
-          <p:cNvSpPr txBox="1"/>
-          <p:nvPr/>
-        </p:nvSpPr>
-        <p:spPr>
-          <a:xfrm>
-            <a:off x="1371600" y="4087368"/>
-            <a:ext cx="2834640" cy="320040"/>
-          </a:xfrm>
-          <a:prstGeom prst="rect">
-            <a:avLst/>
-          </a:prstGeom>
-          <a:noFill/>
-        </p:spPr>
-        <p:txBody>
-          <a:bodyPr wrap="square">
-            <a:spAutoFit/>
-          </a:bodyPr>
-          <a:lstStyle/>
-          <a:p>
-            <a:pPr algn="ctr"/>
-            <a:r>
-              <a:rPr sz="1100" b="0">
-                <a:solidFill>
-                  <a:srgbClr val="FFFFFF"/>
-                </a:solidFill>
-              </a:rPr>
-              <a:t>localhost:5173/architect</a:t>
-            </a:r>
-          </a:p>
-        </p:txBody>
-      </p:sp>
-      <p:sp>
-        <p:nvSpPr>
-          <p:cNvPr id="10" name="Rectangle 9"/>
-          <p:cNvSpPr/>
-          <p:nvPr/>
-        </p:nvSpPr>
-        <p:spPr>
-          <a:xfrm>
-            <a:off x="4572000" y="3657600"/>
-            <a:ext cx="2834640" cy="777240"/>
-          </a:xfrm>
-          <a:prstGeom prst="rect">
-            <a:avLst/>
-          </a:prstGeom>
-          <a:solidFill>
-            <a:srgbClr val="10B981"/>
-          </a:solidFill>
-          <a:ln>
-            <a:noFill/>
-          </a:ln>
-        </p:spPr>
-        <p:style>
-          <a:lnRef idx="1">
-            <a:schemeClr val="accent1"/>
-          </a:lnRef>
-          <a:fillRef idx="3">
-            <a:schemeClr val="accent1"/>
-          </a:fillRef>
-          <a:effectRef idx="2">
-            <a:schemeClr val="accent1"/>
-          </a:effectRef>
-          <a:fontRef idx="minor">
-            <a:schemeClr val="lt1"/>
-          </a:fontRef>
-        </p:style>
-        <p:txBody>
-          <a:bodyPr rtlCol="0" anchor="ctr"/>
-          <a:lstStyle/>
-          <a:p>
-            <a:pPr algn="ctr"/>
-            <a:endParaRPr/>
-          </a:p>
-        </p:txBody>
-      </p:sp>
-      <p:sp>
-        <p:nvSpPr>
-          <p:cNvPr id="11" name="TextBox 10"/>
-          <p:cNvSpPr txBox="1"/>
-          <p:nvPr/>
-        </p:nvSpPr>
-        <p:spPr>
-          <a:xfrm>
-            <a:off x="4572000" y="3703320"/>
-            <a:ext cx="2834640" cy="384048"/>
-          </a:xfrm>
-          <a:prstGeom prst="rect">
-            <a:avLst/>
-          </a:prstGeom>
-          <a:noFill/>
-        </p:spPr>
-        <p:txBody>
-          <a:bodyPr wrap="square">
-            <a:spAutoFit/>
-          </a:bodyPr>
-          <a:lstStyle/>
-          <a:p>
-            <a:pPr algn="ctr"/>
-            <a:r>
-              <a:rPr sz="1400" b="1">
-                <a:solidFill>
-                  <a:srgbClr val="FFFFFF"/>
-                </a:solidFill>
-              </a:rPr>
-              <a:t>📖  API Docs</a:t>
-            </a:r>
-          </a:p>
-        </p:txBody>
-      </p:sp>
-      <p:sp>
-        <p:nvSpPr>
-          <p:cNvPr id="12" name="TextBox 11"/>
-          <p:cNvSpPr txBox="1"/>
-          <p:nvPr/>
-        </p:nvSpPr>
-        <p:spPr>
-          <a:xfrm>
-            <a:off x="4572000" y="4087368"/>
-            <a:ext cx="2834640" cy="320040"/>
-          </a:xfrm>
-          <a:prstGeom prst="rect">
-            <a:avLst/>
-          </a:prstGeom>
-          <a:noFill/>
-        </p:spPr>
-        <p:txBody>
-          <a:bodyPr wrap="square">
-            <a:spAutoFit/>
-          </a:bodyPr>
-          <a:lstStyle/>
-          <a:p>
-            <a:pPr algn="ctr"/>
-            <a:r>
-              <a:rPr sz="1100" b="0">
-                <a:solidFill>
-                  <a:srgbClr val="FFFFFF"/>
-                </a:solidFill>
-              </a:rPr>
-              <a:t>localhost:8000/docs</a:t>
-            </a:r>
-          </a:p>
-        </p:txBody>
-      </p:sp>
-      <p:sp>
-        <p:nvSpPr>
-          <p:cNvPr id="13" name="Rectangle 12"/>
-          <p:cNvSpPr/>
-          <p:nvPr/>
-        </p:nvSpPr>
-        <p:spPr>
-          <a:xfrm>
-            <a:off x="7772400" y="3657600"/>
-            <a:ext cx="2834640" cy="777240"/>
-          </a:xfrm>
-          <a:prstGeom prst="rect">
-            <a:avLst/>
-          </a:prstGeom>
-          <a:solidFill>
-            <a:srgbClr val="F59E0B"/>
-          </a:solidFill>
-          <a:ln>
-            <a:noFill/>
-          </a:ln>
-        </p:spPr>
-        <p:style>
-          <a:lnRef idx="1">
-            <a:schemeClr val="accent1"/>
-          </a:lnRef>
-          <a:fillRef idx="3">
-            <a:schemeClr val="accent1"/>
-          </a:fillRef>
-          <a:effectRef idx="2">
-            <a:schemeClr val="accent1"/>
-          </a:effectRef>
-          <a:fontRef idx="minor">
-            <a:schemeClr val="lt1"/>
-          </a:fontRef>
-        </p:style>
-        <p:txBody>
-          <a:bodyPr rtlCol="0" anchor="ctr"/>
-          <a:lstStyle/>
-          <a:p>
-            <a:pPr algn="ctr"/>
-            <a:endParaRPr/>
-          </a:p>
-        </p:txBody>
-      </p:sp>
-      <p:sp>
-        <p:nvSpPr>
-          <p:cNvPr id="14" name="TextBox 13"/>
-          <p:cNvSpPr txBox="1"/>
-          <p:nvPr/>
-        </p:nvSpPr>
-        <p:spPr>
-          <a:xfrm>
-            <a:off x="7772400" y="3703320"/>
-            <a:ext cx="2834640" cy="384048"/>
-          </a:xfrm>
-          <a:prstGeom prst="rect">
-            <a:avLst/>
-          </a:prstGeom>
-          <a:noFill/>
-        </p:spPr>
-        <p:txBody>
-          <a:bodyPr wrap="square">
-            <a:spAutoFit/>
-          </a:bodyPr>
-          <a:lstStyle/>
-          <a:p>
-            <a:pPr algn="ctr"/>
-            <a:r>
-              <a:rPr sz="1400" b="1">
-                <a:solidFill>
-                  <a:srgbClr val="FFFFFF"/>
-                </a:solidFill>
-              </a:rPr>
-              <a:t>📦  Download ZIP</a:t>
-            </a:r>
-          </a:p>
-        </p:txBody>
-      </p:sp>
-      <p:sp>
-        <p:nvSpPr>
-          <p:cNvPr id="15" name="TextBox 14"/>
-          <p:cNvSpPr txBox="1"/>
-          <p:nvPr/>
-        </p:nvSpPr>
-        <p:spPr>
-          <a:xfrm>
-            <a:off x="7772400" y="4087368"/>
-            <a:ext cx="2834640" cy="320040"/>
-          </a:xfrm>
-          <a:prstGeom prst="rect">
-            <a:avLst/>
-          </a:prstGeom>
-          <a:noFill/>
-        </p:spPr>
-        <p:txBody>
-          <a:bodyPr wrap="square">
-            <a:spAutoFit/>
-          </a:bodyPr>
-          <a:lstStyle/>
-          <a:p>
-            <a:pPr algn="ctr"/>
-            <a:r>
-              <a:rPr sz="1100" b="0">
-                <a:solidFill>
-                  <a:srgbClr val="FFFFFF"/>
-                </a:solidFill>
-              </a:rPr>
-              <a:t>Architect → App → Download</a:t>
-            </a:r>
-          </a:p>
-        </p:txBody>
-      </p:sp>
-      <p:sp>
-        <p:nvSpPr>
-          <p:cNvPr id="16" name="TextBox 15"/>
-          <p:cNvSpPr txBox="1"/>
-          <p:nvPr/>
-        </p:nvSpPr>
-        <p:spPr>
-          <a:xfrm>
-            <a:off x="457200" y="5760720"/>
-            <a:ext cx="10972800" cy="365760"/>
-          </a:xfrm>
-          <a:prstGeom prst="rect">
-            <a:avLst/>
-          </a:prstGeom>
-          <a:noFill/>
-        </p:spPr>
-        <p:txBody>
-          <a:bodyPr wrap="square">
-            <a:spAutoFit/>
-          </a:bodyPr>
-          <a:lstStyle/>
-          <a:p>
-            <a:pPr algn="ctr"/>
-            <a:r>
-              <a:rPr sz="1200" b="0">
+              <a:t>① Templates — pick from 40+ ready-made multi-agent pipelines across 10 categories (Architecture, Sales &amp; Marketing, Customer Support, and more) and load one straight onto the canvas.</a:t>
+            </a:r>
+          </a:p>
+          <a:p>
+            <a:pPr>
+              <a:spcAft>
+                <a:spcPts val="400"/>
+              </a:spcAft>
+            </a:pPr>
+            <a:r>
+              <a:rPr sz="1100">
                 <a:solidFill>
                   <a:srgbClr val="CBD5E1"/>
                 </a:solidFill>
               </a:rPr>
-              <a:t>Accenture Technology  |  n.sureshmanikandan@accenture.com  |  Confidential</a:t>
-            </a:r>
-          </a:p>
-        </p:txBody>
-      </p:sp>
-      <p:sp>
-        <p:nvSpPr>
-          <p:cNvPr id="17" name="TextBox 16"/>
-          <p:cNvSpPr txBox="1"/>
-          <p:nvPr/>
-        </p:nvSpPr>
-        <p:spPr>
-          <a:xfrm>
-            <a:off x="11640312" y="6492240"/>
-            <a:ext cx="457200" cy="320040"/>
-          </a:xfrm>
-          <a:prstGeom prst="rect">
-            <a:avLst/>
-          </a:prstGeom>
-          <a:noFill/>
-        </p:spPr>
-        <p:txBody>
-          <a:bodyPr wrap="square">
-            <a:spAutoFit/>
-          </a:bodyPr>
-          <a:lstStyle/>
-          <a:p>
-            <a:pPr algn="r"/>
-            <a:r>
-              <a:rPr sz="1100" b="0">
-                <a:solidFill>
-                  <a:srgbClr val="CBD5E1"/>
-                </a:solidFill>
-              </a:rPr>
-              <a:t>34</a:t>
+              <a:t>② Auto-Build — describe your pipeline in plain English (“A customer support pipeline that classifies queries, routes to the right responder...”) and GPT-5.4-mini generates a 3–6 role-typed node graph automatically.</a:t>
             </a:r>
           </a:p>
         </p:txBody>
@@ -32194,7 +31881,7 @@
 </file>
 
 <file path=ppt/slides/slide30.xml><?xml version="1.0" encoding="utf-8"?>
-<p:sld xmlns:a="http://schemas.openxmlformats.org/drawingml/2006/main" xmlns:p="http://schemas.openxmlformats.org/presentationml/2006/main" xmlns:r="http://schemas.openxmlformats.org/officeDocument/2006/relationships">
+<p:sld xmlns:a="http://schemas.openxmlformats.org/drawingml/2006/main" xmlns:r="http://schemas.openxmlformats.org/officeDocument/2006/relationships" xmlns:p="http://schemas.openxmlformats.org/presentationml/2006/main">
   <p:cSld>
     <p:spTree>
       <p:nvGrpSpPr>
@@ -32202,7 +31889,14 @@
         <p:cNvGrpSpPr/>
         <p:nvPr/>
       </p:nvGrpSpPr>
-      <p:grpSpPr/>
+      <p:grpSpPr>
+        <a:xfrm>
+          <a:off x="0" y="0"/>
+          <a:ext cx="0" cy="0"/>
+          <a:chOff x="0" y="0"/>
+          <a:chExt cx="0" cy="0"/>
+        </a:xfrm>
+      </p:grpSpPr>
       <p:sp>
         <p:nvSpPr>
           <p:cNvPr id="2" name="Rectangle 1"/>
@@ -32244,6 +31938,7 @@
           <a:lstStyle/>
           <a:p>
             <a:pPr algn="ctr"/>
+            <a:endParaRPr/>
           </a:p>
         </p:txBody>
       </p:sp>
@@ -32288,6 +31983,7 @@
           <a:lstStyle/>
           <a:p>
             <a:pPr algn="ctr"/>
+            <a:endParaRPr/>
           </a:p>
         </p:txBody>
       </p:sp>
@@ -32319,7 +32015,7 @@
                   <a:srgbClr val="FFFFFF"/>
                 </a:solidFill>
               </a:rPr>
-              <a:t>How To Use: Visual Builder — Templates &amp; Auto-Build</a:t>
+              <a:t>How To Use: Visual Builder — Configure, Export &amp; Import</a:t>
             </a:r>
           </a:p>
         </p:txBody>
@@ -32352,14 +32048,14 @@
                   <a:srgbClr val="CBD5E1"/>
                 </a:solidFill>
               </a:rPr>
-              <a:t>29</a:t>
+              <a:t>30</a:t>
             </a:r>
           </a:p>
         </p:txBody>
       </p:sp>
       <p:pic>
         <p:nvPicPr>
-          <p:cNvPr id="6" name="Picture 5" descr="02_builder_templates.png"/>
+          <p:cNvPr id="6" name="Picture 5" descr="04_builder_agent_config.png"/>
           <p:cNvPicPr>
             <a:picLocks noChangeAspect="1"/>
           </p:cNvPicPr>
@@ -32388,7 +32084,7 @@
       </p:pic>
       <p:pic>
         <p:nvPicPr>
-          <p:cNvPr id="7" name="Picture 6" descr="03_builder_autobuild.png"/>
+          <p:cNvPr id="7" name="Picture 6" descr="05_builder_export_code.png"/>
           <p:cNvPicPr>
             <a:picLocks noChangeAspect="1"/>
           </p:cNvPicPr>
@@ -32448,7 +32144,7 @@
                   <a:srgbClr val="CBD5E1"/>
                 </a:solidFill>
               </a:rPr>
-              <a:t>① Templates — pick from 40+ ready-made multi-agent pipelines across 10 categories (Architecture, Sales &amp; Marketing, Customer Support, and more) and load one straight onto the canvas.</a:t>
+              <a:t>① Configure — click any node to set its Role, System Prompt, Model (Local Model or Azure GPT-5.4-mini, per agent), Tools, and always-on Guardrails, then Save Agent.</a:t>
             </a:r>
           </a:p>
           <a:p>
@@ -32463,7 +32159,7 @@
                   <a:srgbClr val="CBD5E1"/>
                 </a:solidFill>
               </a:rPr>
-              <a:t>② Auto-Build — describe your pipeline in plain English (“A customer support pipeline that classifies queries, routes to the right responder...”) and GPT-5.4-mini generates a 3–6 role-typed node graph automatically.</a:t>
+              <a:t>② Export / Import — Export Code generates a faithful Python script with the same execution logic as the live engine; Export JSON / Import JSON give a lossless, round-trippable workflow backup.</a:t>
             </a:r>
           </a:p>
         </p:txBody>
@@ -32477,7 +32173,7 @@
 </file>
 
 <file path=ppt/slides/slide31.xml><?xml version="1.0" encoding="utf-8"?>
-<p:sld xmlns:a="http://schemas.openxmlformats.org/drawingml/2006/main" xmlns:p="http://schemas.openxmlformats.org/presentationml/2006/main" xmlns:r="http://schemas.openxmlformats.org/officeDocument/2006/relationships">
+<p:sld xmlns:a="http://schemas.openxmlformats.org/drawingml/2006/main" xmlns:r="http://schemas.openxmlformats.org/officeDocument/2006/relationships" xmlns:p="http://schemas.openxmlformats.org/presentationml/2006/main">
   <p:cSld>
     <p:spTree>
       <p:nvGrpSpPr>
@@ -32485,7 +32181,14 @@
         <p:cNvGrpSpPr/>
         <p:nvPr/>
       </p:nvGrpSpPr>
-      <p:grpSpPr/>
+      <p:grpSpPr>
+        <a:xfrm>
+          <a:off x="0" y="0"/>
+          <a:ext cx="0" cy="0"/>
+          <a:chOff x="0" y="0"/>
+          <a:chExt cx="0" cy="0"/>
+        </a:xfrm>
+      </p:grpSpPr>
       <p:sp>
         <p:nvSpPr>
           <p:cNvPr id="2" name="Rectangle 1"/>
@@ -32527,6 +32230,7 @@
           <a:lstStyle/>
           <a:p>
             <a:pPr algn="ctr"/>
+            <a:endParaRPr/>
           </a:p>
         </p:txBody>
       </p:sp>
@@ -32571,6 +32275,7 @@
           <a:lstStyle/>
           <a:p>
             <a:pPr algn="ctr"/>
+            <a:endParaRPr/>
           </a:p>
         </p:txBody>
       </p:sp>
@@ -32602,7 +32307,7 @@
                   <a:srgbClr val="FFFFFF"/>
                 </a:solidFill>
               </a:rPr>
-              <a:t>How To Use: Visual Builder — Configure, Export &amp; Import</a:t>
+              <a:t>How To Use: Visual Builder — Run &amp; Deploy</a:t>
             </a:r>
           </a:p>
         </p:txBody>
@@ -32635,14 +32340,14 @@
                   <a:srgbClr val="CBD5E1"/>
                 </a:solidFill>
               </a:rPr>
-              <a:t>30</a:t>
+              <a:t>31</a:t>
             </a:r>
           </a:p>
         </p:txBody>
       </p:sp>
       <p:pic>
         <p:nvPicPr>
-          <p:cNvPr id="6" name="Picture 5" descr="04_builder_agent_config.png"/>
+          <p:cNvPr id="6" name="Picture 5" descr="06_builder_run_dialog.png"/>
           <p:cNvPicPr>
             <a:picLocks noChangeAspect="1"/>
           </p:cNvPicPr>
@@ -32656,8 +32361,8 @@
         </p:blipFill>
         <p:spPr>
           <a:xfrm>
-            <a:off x="457200" y="1051560"/>
-            <a:ext cx="5486400" cy="3086100"/>
+            <a:off x="2651760" y="1051560"/>
+            <a:ext cx="6858000" cy="3857625"/>
           </a:xfrm>
           <a:prstGeom prst="rect">
             <a:avLst/>
@@ -32669,38 +32374,9 @@
           </a:ln>
         </p:spPr>
       </p:pic>
-      <p:pic>
-        <p:nvPicPr>
-          <p:cNvPr id="7" name="Picture 6" descr="05_builder_export_code.png"/>
-          <p:cNvPicPr>
-            <a:picLocks noChangeAspect="1"/>
-          </p:cNvPicPr>
-          <p:nvPr/>
-        </p:nvPicPr>
-        <p:blipFill>
-          <a:blip r:embed="rId3"/>
-          <a:stretch>
-            <a:fillRect/>
-          </a:stretch>
-        </p:blipFill>
-        <p:spPr>
-          <a:xfrm>
-            <a:off x="6172200" y="1051560"/>
-            <a:ext cx="5486400" cy="3086100"/>
-          </a:xfrm>
-          <a:prstGeom prst="rect">
-            <a:avLst/>
-          </a:prstGeom>
-          <a:ln w="12700">
-            <a:solidFill>
-              <a:srgbClr val="334155"/>
-            </a:solidFill>
-          </a:ln>
-        </p:spPr>
-      </p:pic>
-      <p:sp>
-        <p:nvSpPr>
-          <p:cNvPr id="8" name="TextBox 7"/>
+      <p:sp>
+        <p:nvSpPr>
+          <p:cNvPr id="7" name="TextBox 6"/>
           <p:cNvSpPr txBox="1"/>
           <p:nvPr/>
         </p:nvSpPr>
@@ -32731,7 +32407,7 @@
                   <a:srgbClr val="CBD5E1"/>
                 </a:solidFill>
               </a:rPr>
-              <a:t>① Configure — click any node to set its Role, System Prompt, Model (Local Model or Azure GPT-5.4-mini, per agent), Tools, and always-on Guardrails, then Save Agent.</a:t>
+              <a:t>① Run — click Run, and an AI-suggested realistic example input is generated automatically; edit it or keep it, then Execute &amp; Save Trace to watch each node pulse green while running and stay green when done.</a:t>
             </a:r>
           </a:p>
           <a:p>
@@ -32746,7 +32422,7 @@
                   <a:srgbClr val="CBD5E1"/>
                 </a:solidFill>
               </a:rPr>
-              <a:t>② Export / Import — Export Code generates a faithful Python script with the same execution logic as the live engine; Export JSON / Import JSON give a lossless, round-trippable workflow backup.</a:t>
+              <a:t>② Deploy — publish the workflow as a live, callable endpoint once you're happy with a run's trace in Workflow Runs / Observability.</a:t>
             </a:r>
           </a:p>
         </p:txBody>
@@ -32760,7 +32436,7 @@
 </file>
 
 <file path=ppt/slides/slide32.xml><?xml version="1.0" encoding="utf-8"?>
-<p:sld xmlns:a="http://schemas.openxmlformats.org/drawingml/2006/main" xmlns:p="http://schemas.openxmlformats.org/presentationml/2006/main" xmlns:r="http://schemas.openxmlformats.org/officeDocument/2006/relationships">
+<p:sld xmlns:a="http://schemas.openxmlformats.org/drawingml/2006/main" xmlns:r="http://schemas.openxmlformats.org/officeDocument/2006/relationships" xmlns:p="http://schemas.openxmlformats.org/presentationml/2006/main">
   <p:cSld>
     <p:spTree>
       <p:nvGrpSpPr>
@@ -32768,7 +32444,14 @@
         <p:cNvGrpSpPr/>
         <p:nvPr/>
       </p:nvGrpSpPr>
-      <p:grpSpPr/>
+      <p:grpSpPr>
+        <a:xfrm>
+          <a:off x="0" y="0"/>
+          <a:ext cx="0" cy="0"/>
+          <a:chOff x="0" y="0"/>
+          <a:chExt cx="0" cy="0"/>
+        </a:xfrm>
+      </p:grpSpPr>
       <p:sp>
         <p:nvSpPr>
           <p:cNvPr id="2" name="Rectangle 1"/>
@@ -32810,6 +32493,7 @@
           <a:lstStyle/>
           <a:p>
             <a:pPr algn="ctr"/>
+            <a:endParaRPr/>
           </a:p>
         </p:txBody>
       </p:sp>
@@ -32854,6 +32538,7 @@
           <a:lstStyle/>
           <a:p>
             <a:pPr algn="ctr"/>
+            <a:endParaRPr/>
           </a:p>
         </p:txBody>
       </p:sp>
@@ -32885,7 +32570,7 @@
                   <a:srgbClr val="FFFFFF"/>
                 </a:solidFill>
               </a:rPr>
-              <a:t>How To Use: Visual Builder — Run &amp; Deploy</a:t>
+              <a:t>How To Use: Architect, Agent Studio &amp; Playground</a:t>
             </a:r>
           </a:p>
         </p:txBody>
@@ -32918,14 +32603,14 @@
                   <a:srgbClr val="CBD5E1"/>
                 </a:solidFill>
               </a:rPr>
-              <a:t>31</a:t>
+              <a:t>32</a:t>
             </a:r>
           </a:p>
         </p:txBody>
       </p:sp>
       <p:pic>
         <p:nvPicPr>
-          <p:cNvPr id="6" name="Picture 5" descr="06_builder_run_dialog.png"/>
+          <p:cNvPr id="6" name="Picture 5" descr="07_architect.png"/>
           <p:cNvPicPr>
             <a:picLocks noChangeAspect="1"/>
           </p:cNvPicPr>
@@ -32939,8 +32624,8 @@
         </p:blipFill>
         <p:spPr>
           <a:xfrm>
-            <a:off x="2651760" y="1051560"/>
-            <a:ext cx="6858000" cy="3857625"/>
+            <a:off x="457200" y="1051560"/>
+            <a:ext cx="5486400" cy="3086100"/>
           </a:xfrm>
           <a:prstGeom prst="rect">
             <a:avLst/>
@@ -32952,9 +32637,38 @@
           </a:ln>
         </p:spPr>
       </p:pic>
-      <p:sp>
-        <p:nvSpPr>
-          <p:cNvPr id="7" name="TextBox 6"/>
+      <p:pic>
+        <p:nvPicPr>
+          <p:cNvPr id="7" name="Picture 6" descr="08_agent_studio.png"/>
+          <p:cNvPicPr>
+            <a:picLocks noChangeAspect="1"/>
+          </p:cNvPicPr>
+          <p:nvPr/>
+        </p:nvPicPr>
+        <p:blipFill>
+          <a:blip r:embed="rId3"/>
+          <a:stretch>
+            <a:fillRect/>
+          </a:stretch>
+        </p:blipFill>
+        <p:spPr>
+          <a:xfrm>
+            <a:off x="6172200" y="1051560"/>
+            <a:ext cx="5486400" cy="3086100"/>
+          </a:xfrm>
+          <a:prstGeom prst="rect">
+            <a:avLst/>
+          </a:prstGeom>
+          <a:ln w="12700">
+            <a:solidFill>
+              <a:srgbClr val="334155"/>
+            </a:solidFill>
+          </a:ln>
+        </p:spPr>
+      </p:pic>
+      <p:sp>
+        <p:nvSpPr>
+          <p:cNvPr id="8" name="TextBox 7"/>
           <p:cNvSpPr txBox="1"/>
           <p:nvPr/>
         </p:nvSpPr>
@@ -32985,7 +32699,7 @@
                   <a:srgbClr val="CBD5E1"/>
                 </a:solidFill>
               </a:rPr>
-              <a:t>① Run — click Run, and an AI-suggested realistic example input is generated automatically; edit it or keep it, then Execute &amp; Save Trace to watch each node pulse green while running and stay green when done.</a:t>
+              <a:t>① Architect — describe what you want to build in plain English; it asks clarifying questions, then generates a full Plan / Agents / App / Database, downloadable as a RAG Scaffold or Custom Code ZIP.</a:t>
             </a:r>
           </a:p>
           <a:p>
@@ -33000,7 +32714,7 @@
                   <a:srgbClr val="CBD5E1"/>
                 </a:solidFill>
               </a:rPr>
-              <a:t>② Deploy — publish the workflow as a live, callable endpoint once you're happy with a run's trace in Workflow Runs / Observability.</a:t>
+              <a:t>② Agent Studio — every saved agent lives here: Edit, Test, Deploy, Publish, or ask it something directly. Playground gives each agent its own chat with a one-click “Suggest” example-input button.</a:t>
             </a:r>
           </a:p>
         </p:txBody>
@@ -33014,7 +32728,7 @@
 </file>
 
 <file path=ppt/slides/slide33.xml><?xml version="1.0" encoding="utf-8"?>
-<p:sld xmlns:a="http://schemas.openxmlformats.org/drawingml/2006/main" xmlns:p="http://schemas.openxmlformats.org/presentationml/2006/main" xmlns:r="http://schemas.openxmlformats.org/officeDocument/2006/relationships">
+<p:sld xmlns:a="http://schemas.openxmlformats.org/drawingml/2006/main" xmlns:r="http://schemas.openxmlformats.org/officeDocument/2006/relationships" xmlns:p="http://schemas.openxmlformats.org/presentationml/2006/main">
   <p:cSld>
     <p:spTree>
       <p:nvGrpSpPr>
@@ -33022,7 +32736,14 @@
         <p:cNvGrpSpPr/>
         <p:nvPr/>
       </p:nvGrpSpPr>
-      <p:grpSpPr/>
+      <p:grpSpPr>
+        <a:xfrm>
+          <a:off x="0" y="0"/>
+          <a:ext cx="0" cy="0"/>
+          <a:chOff x="0" y="0"/>
+          <a:chExt cx="0" cy="0"/>
+        </a:xfrm>
+      </p:grpSpPr>
       <p:sp>
         <p:nvSpPr>
           <p:cNvPr id="2" name="Rectangle 1"/>
@@ -33064,6 +32785,7 @@
           <a:lstStyle/>
           <a:p>
             <a:pPr algn="ctr"/>
+            <a:endParaRPr/>
           </a:p>
         </p:txBody>
       </p:sp>
@@ -33108,6 +32830,7 @@
           <a:lstStyle/>
           <a:p>
             <a:pPr algn="ctr"/>
+            <a:endParaRPr/>
           </a:p>
         </p:txBody>
       </p:sp>
@@ -33139,7 +32862,7 @@
                   <a:srgbClr val="FFFFFF"/>
                 </a:solidFill>
               </a:rPr>
-              <a:t>How To Use: Architect, Agent Studio &amp; Playground</a:t>
+              <a:t>How To Use: Playground — Test Any Agent Live</a:t>
             </a:r>
           </a:p>
         </p:txBody>
@@ -33172,43 +32895,67 @@
                   <a:srgbClr val="CBD5E1"/>
                 </a:solidFill>
               </a:rPr>
-              <a:t>32</a:t>
+              <a:t>33</a:t>
+            </a:r>
+          </a:p>
+        </p:txBody>
+      </p:sp>
+      <p:sp>
+        <p:nvSpPr>
+          <p:cNvPr id="7" name="TextBox 6"/>
+          <p:cNvSpPr txBox="1"/>
+          <p:nvPr/>
+        </p:nvSpPr>
+        <p:spPr>
+          <a:xfrm>
+            <a:off x="457200" y="5440680"/>
+            <a:ext cx="11247120" cy="1188720"/>
+          </a:xfrm>
+          <a:prstGeom prst="rect">
+            <a:avLst/>
+          </a:prstGeom>
+          <a:noFill/>
+        </p:spPr>
+        <p:txBody>
+          <a:bodyPr wrap="square">
+            <a:spAutoFit/>
+          </a:bodyPr>
+          <a:lstStyle/>
+          <a:p>
+            <a:pPr>
+              <a:spcAft>
+                <a:spcPts val="400"/>
+              </a:spcAft>
+            </a:pPr>
+            <a:r>
+              <a:rPr sz="1100">
+                <a:solidFill>
+                  <a:srgbClr val="CBD5E1"/>
+                </a:solidFill>
+              </a:rPr>
+              <a:t>① Open any agent's Playground to see its System Prompt, Guardrails, Tools, and the exact Model it runs on (accurately resolved per agent — Local Model or Azure GPT-5.4-mini, not a stale label).</a:t>
+            </a:r>
+          </a:p>
+          <a:p>
+            <a:pPr>
+              <a:spcAft>
+                <a:spcPts val="400"/>
+              </a:spcAft>
+            </a:pPr>
+            <a:r>
+              <a:rPr sz="1100">
+                <a:solidFill>
+                  <a:srgbClr val="CBD5E1"/>
+                </a:solidFill>
+              </a:rPr>
+              <a:t>② Click Suggest for an AI-generated realistic example message tailored to that agent, or type your own — then Send to test it live and watch Session Stats (Total Runs, Avg ms) update.</a:t>
             </a:r>
           </a:p>
         </p:txBody>
       </p:sp>
       <p:pic>
         <p:nvPicPr>
-          <p:cNvPr id="6" name="Picture 5" descr="07_architect.png"/>
-          <p:cNvPicPr>
-            <a:picLocks noChangeAspect="1"/>
-          </p:cNvPicPr>
-          <p:nvPr/>
-        </p:nvPicPr>
-        <p:blipFill>
-          <a:blip r:embed="rId2"/>
-          <a:stretch>
-            <a:fillRect/>
-          </a:stretch>
-        </p:blipFill>
-        <p:spPr>
-          <a:xfrm>
-            <a:off x="457200" y="1051560"/>
-            <a:ext cx="5486400" cy="3086100"/>
-          </a:xfrm>
-          <a:prstGeom prst="rect">
-            <a:avLst/>
-          </a:prstGeom>
-          <a:ln w="12700">
-            <a:solidFill>
-              <a:srgbClr val="334155"/>
-            </a:solidFill>
-          </a:ln>
-        </p:spPr>
-      </p:pic>
-      <p:pic>
-        <p:nvPicPr>
-          <p:cNvPr id="7" name="Picture 6" descr="08_agent_studio.png"/>
+          <p:cNvPr id="8" name="Picture 7" descr="10_playground_suggest.png"/>
           <p:cNvPicPr>
             <a:picLocks noChangeAspect="1"/>
           </p:cNvPicPr>
@@ -33222,8 +32969,8 @@
         </p:blipFill>
         <p:spPr>
           <a:xfrm>
-            <a:off x="6172200" y="1051560"/>
-            <a:ext cx="5486400" cy="3086100"/>
+            <a:off x="2651760" y="1051560"/>
+            <a:ext cx="6858000" cy="3857625"/>
           </a:xfrm>
           <a:prstGeom prst="rect">
             <a:avLst/>
@@ -33235,59 +32982,6 @@
           </a:ln>
         </p:spPr>
       </p:pic>
-      <p:sp>
-        <p:nvSpPr>
-          <p:cNvPr id="8" name="TextBox 7"/>
-          <p:cNvSpPr txBox="1"/>
-          <p:nvPr/>
-        </p:nvSpPr>
-        <p:spPr>
-          <a:xfrm>
-            <a:off x="457200" y="5440680"/>
-            <a:ext cx="11247120" cy="1188720"/>
-          </a:xfrm>
-          <a:prstGeom prst="rect">
-            <a:avLst/>
-          </a:prstGeom>
-          <a:noFill/>
-        </p:spPr>
-        <p:txBody>
-          <a:bodyPr wrap="square">
-            <a:spAutoFit/>
-          </a:bodyPr>
-          <a:lstStyle/>
-          <a:p>
-            <a:pPr>
-              <a:spcAft>
-                <a:spcPts val="400"/>
-              </a:spcAft>
-            </a:pPr>
-            <a:r>
-              <a:rPr sz="1100">
-                <a:solidFill>
-                  <a:srgbClr val="CBD5E1"/>
-                </a:solidFill>
-              </a:rPr>
-              <a:t>① Architect — describe what you want to build in plain English; it asks clarifying questions, then generates a full Plan / Agents / App / Database, downloadable as a RAG Scaffold or Custom Code ZIP.</a:t>
-            </a:r>
-          </a:p>
-          <a:p>
-            <a:pPr>
-              <a:spcAft>
-                <a:spcPts val="400"/>
-              </a:spcAft>
-            </a:pPr>
-            <a:r>
-              <a:rPr sz="1100">
-                <a:solidFill>
-                  <a:srgbClr val="CBD5E1"/>
-                </a:solidFill>
-              </a:rPr>
-              <a:t>② Agent Studio — every saved agent lives here: Edit, Test, Deploy, Publish, or ask it something directly. Playground gives each agent its own chat with a one-click “Suggest” example-input button.</a:t>
-            </a:r>
-          </a:p>
-        </p:txBody>
-      </p:sp>
     </p:spTree>
   </p:cSld>
   <p:clrMapOvr>
@@ -33422,7 +33116,7 @@
                   <a:srgbClr val="FFFFFF"/>
                 </a:solidFill>
               </a:rPr>
-              <a:t>How To Use: Playground — Test Any Agent Live</a:t>
+              <a:t>How To Use: Home &amp; Prompt Library</a:t>
             </a:r>
           </a:p>
         </p:txBody>
@@ -33455,14 +33149,14 @@
                   <a:srgbClr val="CBD5E1"/>
                 </a:solidFill>
               </a:rPr>
-              <a:t>33</a:t>
+              <a:t>34</a:t>
             </a:r>
           </a:p>
         </p:txBody>
       </p:sp>
       <p:pic>
         <p:nvPicPr>
-          <p:cNvPr id="6" name="Picture 5" descr="10_playground_suggest.png"/>
+          <p:cNvPr id="6" name="Picture 5" descr="11_home.png"/>
           <p:cNvPicPr>
             <a:picLocks noChangeAspect="1"/>
           </p:cNvPicPr>
@@ -33476,8 +33170,8 @@
         </p:blipFill>
         <p:spPr>
           <a:xfrm>
-            <a:off x="2651760" y="1051560"/>
-            <a:ext cx="6858000" cy="3857625"/>
+            <a:off x="457200" y="1051560"/>
+            <a:ext cx="5486400" cy="3086100"/>
           </a:xfrm>
           <a:prstGeom prst="rect">
             <a:avLst/>
@@ -33489,9 +33183,38 @@
           </a:ln>
         </p:spPr>
       </p:pic>
-      <p:sp>
-        <p:nvSpPr>
-          <p:cNvPr id="7" name="TextBox 6"/>
+      <p:pic>
+        <p:nvPicPr>
+          <p:cNvPr id="7" name="Picture 6" descr="12_prompt_library.png"/>
+          <p:cNvPicPr>
+            <a:picLocks noChangeAspect="1"/>
+          </p:cNvPicPr>
+          <p:nvPr/>
+        </p:nvPicPr>
+        <p:blipFill>
+          <a:blip r:embed="rId3"/>
+          <a:stretch>
+            <a:fillRect/>
+          </a:stretch>
+        </p:blipFill>
+        <p:spPr>
+          <a:xfrm>
+            <a:off x="6172200" y="1051560"/>
+            <a:ext cx="5486400" cy="3086100"/>
+          </a:xfrm>
+          <a:prstGeom prst="rect">
+            <a:avLst/>
+          </a:prstGeom>
+          <a:ln w="12700">
+            <a:solidFill>
+              <a:srgbClr val="334155"/>
+            </a:solidFill>
+          </a:ln>
+        </p:spPr>
+      </p:pic>
+      <p:sp>
+        <p:nvSpPr>
+          <p:cNvPr id="8" name="TextBox 7"/>
           <p:cNvSpPr txBox="1"/>
           <p:nvPr/>
         </p:nvSpPr>
@@ -33522,7 +33245,7 @@
                   <a:srgbClr val="CBD5E1"/>
                 </a:solidFill>
               </a:rPr>
-              <a:t>① Open any agent's Playground to see its System Prompt, Guardrails, Tools, and the exact Model it runs on (accurately resolved per agent — Local Model or Azure GPT-5.4-mini, not a stale label).</a:t>
+              <a:t>① Home — landing page with quick actions and recent activity; the fastest way back into any agent, project, or workflow you were last working on.</a:t>
             </a:r>
           </a:p>
           <a:p>
@@ -33537,7 +33260,1173 @@
                   <a:srgbClr val="CBD5E1"/>
                 </a:solidFill>
               </a:rPr>
-              <a:t>② Click Suggest for an AI-generated realistic example message tailored to that agent, or type your own — then Send to test it live and watch Session Stats (Total Runs, Avg ms) update.</a:t>
+              <a:t>② Prompt Library — 46+ curated multi-agent prompts across 10 domains (Support, Sales, Legal, HR, Data, and more); search, preview, and copy straight into Architect or Agent Studio.</a:t>
+            </a:r>
+          </a:p>
+        </p:txBody>
+      </p:sp>
+    </p:spTree>
+  </p:cSld>
+  <p:clrMapOvr>
+    <a:masterClrMapping/>
+  </p:clrMapOvr>
+</p:sld>
+</file>
+
+<file path=ppt/slides/slide35.xml><?xml version="1.0" encoding="utf-8"?>
+<p:sld xmlns:a="http://schemas.openxmlformats.org/drawingml/2006/main" xmlns:p="http://schemas.openxmlformats.org/presentationml/2006/main" xmlns:r="http://schemas.openxmlformats.org/officeDocument/2006/relationships">
+  <p:cSld>
+    <p:spTree>
+      <p:nvGrpSpPr>
+        <p:cNvPr id="1" name=""/>
+        <p:cNvGrpSpPr/>
+        <p:nvPr/>
+      </p:nvGrpSpPr>
+      <p:grpSpPr/>
+      <p:sp>
+        <p:nvSpPr>
+          <p:cNvPr id="2" name="Rectangle 1"/>
+          <p:cNvSpPr/>
+          <p:nvPr/>
+        </p:nvSpPr>
+        <p:spPr>
+          <a:xfrm>
+            <a:off x="0" y="0"/>
+            <a:ext cx="12188825" cy="6858000"/>
+          </a:xfrm>
+          <a:prstGeom prst="rect">
+            <a:avLst/>
+          </a:prstGeom>
+          <a:solidFill>
+            <a:srgbClr val="0F172A"/>
+          </a:solidFill>
+          <a:ln>
+            <a:noFill/>
+          </a:ln>
+          <a:effectLst/>
+        </p:spPr>
+        <p:style>
+          <a:lnRef idx="1">
+            <a:schemeClr val="accent1"/>
+          </a:lnRef>
+          <a:fillRef idx="3">
+            <a:schemeClr val="accent1"/>
+          </a:fillRef>
+          <a:effectRef idx="2">
+            <a:schemeClr val="accent1"/>
+          </a:effectRef>
+          <a:fontRef idx="minor">
+            <a:schemeClr val="lt1"/>
+          </a:fontRef>
+        </p:style>
+        <p:txBody>
+          <a:bodyPr rtlCol="0" anchor="ctr"/>
+          <a:lstStyle/>
+          <a:p>
+            <a:pPr algn="ctr"/>
+          </a:p>
+        </p:txBody>
+      </p:sp>
+      <p:sp>
+        <p:nvSpPr>
+          <p:cNvPr id="3" name="Rectangle 2"/>
+          <p:cNvSpPr/>
+          <p:nvPr/>
+        </p:nvSpPr>
+        <p:spPr>
+          <a:xfrm>
+            <a:off x="0" y="73152"/>
+            <a:ext cx="12188825" cy="45720"/>
+          </a:xfrm>
+          <a:prstGeom prst="rect">
+            <a:avLst/>
+          </a:prstGeom>
+          <a:solidFill>
+            <a:srgbClr val="606EF5"/>
+          </a:solidFill>
+          <a:ln>
+            <a:noFill/>
+          </a:ln>
+          <a:effectLst/>
+        </p:spPr>
+        <p:style>
+          <a:lnRef idx="1">
+            <a:schemeClr val="accent1"/>
+          </a:lnRef>
+          <a:fillRef idx="3">
+            <a:schemeClr val="accent1"/>
+          </a:fillRef>
+          <a:effectRef idx="2">
+            <a:schemeClr val="accent1"/>
+          </a:effectRef>
+          <a:fontRef idx="minor">
+            <a:schemeClr val="lt1"/>
+          </a:fontRef>
+        </p:style>
+        <p:txBody>
+          <a:bodyPr rtlCol="0" anchor="ctr"/>
+          <a:lstStyle/>
+          <a:p>
+            <a:pPr algn="ctr"/>
+          </a:p>
+        </p:txBody>
+      </p:sp>
+      <p:sp>
+        <p:nvSpPr>
+          <p:cNvPr id="4" name="TextBox 3"/>
+          <p:cNvSpPr txBox="1"/>
+          <p:nvPr/>
+        </p:nvSpPr>
+        <p:spPr>
+          <a:xfrm>
+            <a:off x="457200" y="274320"/>
+            <a:ext cx="10972800" cy="548640"/>
+          </a:xfrm>
+          <a:prstGeom prst="rect">
+            <a:avLst/>
+          </a:prstGeom>
+          <a:noFill/>
+        </p:spPr>
+        <p:txBody>
+          <a:bodyPr wrap="square">
+            <a:spAutoFit/>
+          </a:bodyPr>
+          <a:lstStyle/>
+          <a:p>
+            <a:r>
+              <a:rPr sz="2600" b="1">
+                <a:solidFill>
+                  <a:srgbClr val="FFFFFF"/>
+                </a:solidFill>
+              </a:rPr>
+              <a:t>How To Use: Control Plane &amp; Audit Traceability</a:t>
+            </a:r>
+          </a:p>
+        </p:txBody>
+      </p:sp>
+      <p:sp>
+        <p:nvSpPr>
+          <p:cNvPr id="5" name="TextBox 4"/>
+          <p:cNvSpPr txBox="1"/>
+          <p:nvPr/>
+        </p:nvSpPr>
+        <p:spPr>
+          <a:xfrm>
+            <a:off x="11731752" y="6492240"/>
+            <a:ext cx="457200" cy="320040"/>
+          </a:xfrm>
+          <a:prstGeom prst="rect">
+            <a:avLst/>
+          </a:prstGeom>
+          <a:noFill/>
+        </p:spPr>
+        <p:txBody>
+          <a:bodyPr wrap="none">
+            <a:spAutoFit/>
+          </a:bodyPr>
+          <a:lstStyle/>
+          <a:p>
+            <a:r>
+              <a:rPr sz="1100">
+                <a:solidFill>
+                  <a:srgbClr val="CBD5E1"/>
+                </a:solidFill>
+              </a:rPr>
+              <a:t>35</a:t>
+            </a:r>
+          </a:p>
+        </p:txBody>
+      </p:sp>
+      <p:pic>
+        <p:nvPicPr>
+          <p:cNvPr id="6" name="Picture 5" descr="13_control_plane.png"/>
+          <p:cNvPicPr>
+            <a:picLocks noChangeAspect="1"/>
+          </p:cNvPicPr>
+          <p:nvPr/>
+        </p:nvPicPr>
+        <p:blipFill>
+          <a:blip r:embed="rId2"/>
+          <a:stretch>
+            <a:fillRect/>
+          </a:stretch>
+        </p:blipFill>
+        <p:spPr>
+          <a:xfrm>
+            <a:off x="457200" y="1051560"/>
+            <a:ext cx="5486400" cy="3086100"/>
+          </a:xfrm>
+          <a:prstGeom prst="rect">
+            <a:avLst/>
+          </a:prstGeom>
+          <a:ln w="12700">
+            <a:solidFill>
+              <a:srgbClr val="334155"/>
+            </a:solidFill>
+          </a:ln>
+        </p:spPr>
+      </p:pic>
+      <p:pic>
+        <p:nvPicPr>
+          <p:cNvPr id="7" name="Picture 6" descr="14_usage_audit.png"/>
+          <p:cNvPicPr>
+            <a:picLocks noChangeAspect="1"/>
+          </p:cNvPicPr>
+          <p:nvPr/>
+        </p:nvPicPr>
+        <p:blipFill>
+          <a:blip r:embed="rId3"/>
+          <a:stretch>
+            <a:fillRect/>
+          </a:stretch>
+        </p:blipFill>
+        <p:spPr>
+          <a:xfrm>
+            <a:off x="6172200" y="1051560"/>
+            <a:ext cx="5486400" cy="3086100"/>
+          </a:xfrm>
+          <a:prstGeom prst="rect">
+            <a:avLst/>
+          </a:prstGeom>
+          <a:ln w="12700">
+            <a:solidFill>
+              <a:srgbClr val="334155"/>
+            </a:solidFill>
+          </a:ln>
+        </p:spPr>
+      </p:pic>
+      <p:sp>
+        <p:nvSpPr>
+          <p:cNvPr id="8" name="TextBox 7"/>
+          <p:cNvSpPr txBox="1"/>
+          <p:nvPr/>
+        </p:nvSpPr>
+        <p:spPr>
+          <a:xfrm>
+            <a:off x="457200" y="5440680"/>
+            <a:ext cx="11247120" cy="1188720"/>
+          </a:xfrm>
+          <a:prstGeom prst="rect">
+            <a:avLst/>
+          </a:prstGeom>
+          <a:noFill/>
+        </p:spPr>
+        <p:txBody>
+          <a:bodyPr wrap="square">
+            <a:spAutoFit/>
+          </a:bodyPr>
+          <a:lstStyle/>
+          <a:p>
+            <a:pPr>
+              <a:spcAft>
+                <a:spcPts val="400"/>
+              </a:spcAft>
+            </a:pPr>
+            <a:r>
+              <a:rPr sz="1100">
+                <a:solidFill>
+                  <a:srgbClr val="CBD5E1"/>
+                </a:solidFill>
+              </a:rPr>
+              <a:t>① Control Plane — live platform health: active agents, runs, guardrail triggers, and average latency in one dashboard, refreshed in real time.</a:t>
+            </a:r>
+          </a:p>
+          <a:p>
+            <a:pPr>
+              <a:spcAft>
+                <a:spcPts val="400"/>
+              </a:spcAft>
+            </a:pPr>
+            <a:r>
+              <a:rPr sz="1100">
+                <a:solidFill>
+                  <a:srgbClr val="CBD5E1"/>
+                </a:solidFill>
+              </a:rPr>
+              <a:t>② Usage &amp; Traceability — full audit-log viewer: every agent action with user, resource, input/output snapshot, guardrail trigger, latency, and trace ID, filterable by action/agent/date.</a:t>
+            </a:r>
+          </a:p>
+        </p:txBody>
+      </p:sp>
+    </p:spTree>
+  </p:cSld>
+  <p:clrMapOvr>
+    <a:masterClrMapping/>
+  </p:clrMapOvr>
+</p:sld>
+</file>
+
+<file path=ppt/slides/slide36.xml><?xml version="1.0" encoding="utf-8"?>
+<p:sld xmlns:a="http://schemas.openxmlformats.org/drawingml/2006/main" xmlns:p="http://schemas.openxmlformats.org/presentationml/2006/main" xmlns:r="http://schemas.openxmlformats.org/officeDocument/2006/relationships">
+  <p:cSld>
+    <p:spTree>
+      <p:nvGrpSpPr>
+        <p:cNvPr id="1" name=""/>
+        <p:cNvGrpSpPr/>
+        <p:nvPr/>
+      </p:nvGrpSpPr>
+      <p:grpSpPr/>
+      <p:sp>
+        <p:nvSpPr>
+          <p:cNvPr id="2" name="Rectangle 1"/>
+          <p:cNvSpPr/>
+          <p:nvPr/>
+        </p:nvSpPr>
+        <p:spPr>
+          <a:xfrm>
+            <a:off x="0" y="0"/>
+            <a:ext cx="12188825" cy="6858000"/>
+          </a:xfrm>
+          <a:prstGeom prst="rect">
+            <a:avLst/>
+          </a:prstGeom>
+          <a:solidFill>
+            <a:srgbClr val="0F172A"/>
+          </a:solidFill>
+          <a:ln>
+            <a:noFill/>
+          </a:ln>
+          <a:effectLst/>
+        </p:spPr>
+        <p:style>
+          <a:lnRef idx="1">
+            <a:schemeClr val="accent1"/>
+          </a:lnRef>
+          <a:fillRef idx="3">
+            <a:schemeClr val="accent1"/>
+          </a:fillRef>
+          <a:effectRef idx="2">
+            <a:schemeClr val="accent1"/>
+          </a:effectRef>
+          <a:fontRef idx="minor">
+            <a:schemeClr val="lt1"/>
+          </a:fontRef>
+        </p:style>
+        <p:txBody>
+          <a:bodyPr rtlCol="0" anchor="ctr"/>
+          <a:lstStyle/>
+          <a:p>
+            <a:pPr algn="ctr"/>
+          </a:p>
+        </p:txBody>
+      </p:sp>
+      <p:sp>
+        <p:nvSpPr>
+          <p:cNvPr id="3" name="Rectangle 2"/>
+          <p:cNvSpPr/>
+          <p:nvPr/>
+        </p:nvSpPr>
+        <p:spPr>
+          <a:xfrm>
+            <a:off x="0" y="73152"/>
+            <a:ext cx="12188825" cy="45720"/>
+          </a:xfrm>
+          <a:prstGeom prst="rect">
+            <a:avLst/>
+          </a:prstGeom>
+          <a:solidFill>
+            <a:srgbClr val="606EF5"/>
+          </a:solidFill>
+          <a:ln>
+            <a:noFill/>
+          </a:ln>
+          <a:effectLst/>
+        </p:spPr>
+        <p:style>
+          <a:lnRef idx="1">
+            <a:schemeClr val="accent1"/>
+          </a:lnRef>
+          <a:fillRef idx="3">
+            <a:schemeClr val="accent1"/>
+          </a:fillRef>
+          <a:effectRef idx="2">
+            <a:schemeClr val="accent1"/>
+          </a:effectRef>
+          <a:fontRef idx="minor">
+            <a:schemeClr val="lt1"/>
+          </a:fontRef>
+        </p:style>
+        <p:txBody>
+          <a:bodyPr rtlCol="0" anchor="ctr"/>
+          <a:lstStyle/>
+          <a:p>
+            <a:pPr algn="ctr"/>
+          </a:p>
+        </p:txBody>
+      </p:sp>
+      <p:sp>
+        <p:nvSpPr>
+          <p:cNvPr id="4" name="TextBox 3"/>
+          <p:cNvSpPr txBox="1"/>
+          <p:nvPr/>
+        </p:nvSpPr>
+        <p:spPr>
+          <a:xfrm>
+            <a:off x="457200" y="274320"/>
+            <a:ext cx="10972800" cy="548640"/>
+          </a:xfrm>
+          <a:prstGeom prst="rect">
+            <a:avLst/>
+          </a:prstGeom>
+          <a:noFill/>
+        </p:spPr>
+        <p:txBody>
+          <a:bodyPr wrap="square">
+            <a:spAutoFit/>
+          </a:bodyPr>
+          <a:lstStyle/>
+          <a:p>
+            <a:r>
+              <a:rPr sz="2600" b="1">
+                <a:solidFill>
+                  <a:srgbClr val="FFFFFF"/>
+                </a:solidFill>
+              </a:rPr>
+              <a:t>How To Use: Workflow Observability — Tracing &amp; Logs</a:t>
+            </a:r>
+          </a:p>
+        </p:txBody>
+      </p:sp>
+      <p:sp>
+        <p:nvSpPr>
+          <p:cNvPr id="5" name="TextBox 4"/>
+          <p:cNvSpPr txBox="1"/>
+          <p:nvPr/>
+        </p:nvSpPr>
+        <p:spPr>
+          <a:xfrm>
+            <a:off x="11731752" y="6492240"/>
+            <a:ext cx="457200" cy="320040"/>
+          </a:xfrm>
+          <a:prstGeom prst="rect">
+            <a:avLst/>
+          </a:prstGeom>
+          <a:noFill/>
+        </p:spPr>
+        <p:txBody>
+          <a:bodyPr wrap="none">
+            <a:spAutoFit/>
+          </a:bodyPr>
+          <a:lstStyle/>
+          <a:p>
+            <a:r>
+              <a:rPr sz="1100">
+                <a:solidFill>
+                  <a:srgbClr val="CBD5E1"/>
+                </a:solidFill>
+              </a:rPr>
+              <a:t>36</a:t>
+            </a:r>
+          </a:p>
+        </p:txBody>
+      </p:sp>
+      <p:pic>
+        <p:nvPicPr>
+          <p:cNvPr id="6" name="Picture 5" descr="15_workflow_observability.png"/>
+          <p:cNvPicPr>
+            <a:picLocks noChangeAspect="1"/>
+          </p:cNvPicPr>
+          <p:nvPr/>
+        </p:nvPicPr>
+        <p:blipFill>
+          <a:blip r:embed="rId2"/>
+          <a:stretch>
+            <a:fillRect/>
+          </a:stretch>
+        </p:blipFill>
+        <p:spPr>
+          <a:xfrm>
+            <a:off x="1737360" y="1051560"/>
+            <a:ext cx="8686800" cy="4886325"/>
+          </a:xfrm>
+          <a:prstGeom prst="rect">
+            <a:avLst/>
+          </a:prstGeom>
+          <a:ln w="12700">
+            <a:solidFill>
+              <a:srgbClr val="334155"/>
+            </a:solidFill>
+          </a:ln>
+        </p:spPr>
+      </p:pic>
+      <p:sp>
+        <p:nvSpPr>
+          <p:cNvPr id="7" name="TextBox 6"/>
+          <p:cNvSpPr txBox="1"/>
+          <p:nvPr/>
+        </p:nvSpPr>
+        <p:spPr>
+          <a:xfrm>
+            <a:off x="457200" y="5440680"/>
+            <a:ext cx="11247120" cy="1188720"/>
+          </a:xfrm>
+          <a:prstGeom prst="rect">
+            <a:avLst/>
+          </a:prstGeom>
+          <a:noFill/>
+        </p:spPr>
+        <p:txBody>
+          <a:bodyPr wrap="square">
+            <a:spAutoFit/>
+          </a:bodyPr>
+          <a:lstStyle/>
+          <a:p>
+            <a:pPr>
+              <a:spcAft>
+                <a:spcPts val="400"/>
+              </a:spcAft>
+            </a:pPr>
+            <a:r>
+              <a:rPr sz="1100">
+                <a:solidFill>
+                  <a:srgbClr val="CBD5E1"/>
+                </a:solidFill>
+              </a:rPr>
+              <a:t>① Every workflow run is logged here with per-node execution trace, total duration, and final status — including an “Awaiting Approval” count with a direct “Review →” link for paused runs.</a:t>
+            </a:r>
+          </a:p>
+          <a:p>
+            <a:pPr>
+              <a:spcAft>
+                <a:spcPts val="400"/>
+              </a:spcAft>
+            </a:pPr>
+            <a:r>
+              <a:rPr sz="1100">
+                <a:solidFill>
+                  <a:srgbClr val="CBD5E1"/>
+                </a:solidFill>
+              </a:rPr>
+              <a:t>② Backed by real OpenTelemetry spans on every LLM call, so a slow or failed run can be traced back to the exact node, prompt, and latency that caused it — not a black box.</a:t>
+            </a:r>
+          </a:p>
+        </p:txBody>
+      </p:sp>
+    </p:spTree>
+  </p:cSld>
+  <p:clrMapOvr>
+    <a:masterClrMapping/>
+  </p:clrMapOvr>
+</p:sld>
+</file>
+
+<file path=ppt/slides/slide37.xml><?xml version="1.0" encoding="utf-8"?>
+<p:sld xmlns:a="http://schemas.openxmlformats.org/drawingml/2006/main" xmlns:r="http://schemas.openxmlformats.org/officeDocument/2006/relationships" xmlns:p="http://schemas.openxmlformats.org/presentationml/2006/main">
+  <p:cSld>
+    <p:spTree>
+      <p:nvGrpSpPr>
+        <p:cNvPr id="1" name=""/>
+        <p:cNvGrpSpPr/>
+        <p:nvPr/>
+      </p:nvGrpSpPr>
+      <p:grpSpPr>
+        <a:xfrm>
+          <a:off x="0" y="0"/>
+          <a:ext cx="0" cy="0"/>
+          <a:chOff x="0" y="0"/>
+          <a:chExt cx="0" cy="0"/>
+        </a:xfrm>
+      </p:grpSpPr>
+      <p:sp>
+        <p:nvSpPr>
+          <p:cNvPr id="2" name="Rectangle 1"/>
+          <p:cNvSpPr/>
+          <p:nvPr/>
+        </p:nvSpPr>
+        <p:spPr>
+          <a:xfrm>
+            <a:off x="0" y="0"/>
+            <a:ext cx="12188952" cy="6858000"/>
+          </a:xfrm>
+          <a:prstGeom prst="rect">
+            <a:avLst/>
+          </a:prstGeom>
+          <a:solidFill>
+            <a:srgbClr val="0F172A"/>
+          </a:solidFill>
+          <a:ln>
+            <a:noFill/>
+          </a:ln>
+        </p:spPr>
+        <p:style>
+          <a:lnRef idx="1">
+            <a:schemeClr val="accent1"/>
+          </a:lnRef>
+          <a:fillRef idx="3">
+            <a:schemeClr val="accent1"/>
+          </a:fillRef>
+          <a:effectRef idx="2">
+            <a:schemeClr val="accent1"/>
+          </a:effectRef>
+          <a:fontRef idx="minor">
+            <a:schemeClr val="lt1"/>
+          </a:fontRef>
+        </p:style>
+        <p:txBody>
+          <a:bodyPr rtlCol="0" anchor="ctr"/>
+          <a:lstStyle/>
+          <a:p>
+            <a:pPr algn="ctr"/>
+            <a:endParaRPr/>
+          </a:p>
+        </p:txBody>
+      </p:sp>
+      <p:sp>
+        <p:nvSpPr>
+          <p:cNvPr id="3" name="Rectangle 2"/>
+          <p:cNvSpPr/>
+          <p:nvPr/>
+        </p:nvSpPr>
+        <p:spPr>
+          <a:xfrm>
+            <a:off x="0" y="0"/>
+            <a:ext cx="12188952" cy="45720"/>
+          </a:xfrm>
+          <a:prstGeom prst="rect">
+            <a:avLst/>
+          </a:prstGeom>
+          <a:solidFill>
+            <a:srgbClr val="606EF5"/>
+          </a:solidFill>
+          <a:ln>
+            <a:noFill/>
+          </a:ln>
+        </p:spPr>
+        <p:style>
+          <a:lnRef idx="1">
+            <a:schemeClr val="accent1"/>
+          </a:lnRef>
+          <a:fillRef idx="3">
+            <a:schemeClr val="accent1"/>
+          </a:fillRef>
+          <a:effectRef idx="2">
+            <a:schemeClr val="accent1"/>
+          </a:effectRef>
+          <a:fontRef idx="minor">
+            <a:schemeClr val="lt1"/>
+          </a:fontRef>
+        </p:style>
+        <p:txBody>
+          <a:bodyPr rtlCol="0" anchor="ctr"/>
+          <a:lstStyle/>
+          <a:p>
+            <a:pPr algn="ctr"/>
+            <a:endParaRPr/>
+          </a:p>
+        </p:txBody>
+      </p:sp>
+      <p:sp>
+        <p:nvSpPr>
+          <p:cNvPr id="4" name="Rectangle 3"/>
+          <p:cNvSpPr/>
+          <p:nvPr/>
+        </p:nvSpPr>
+        <p:spPr>
+          <a:xfrm>
+            <a:off x="0" y="1371600"/>
+            <a:ext cx="12188952" cy="4114800"/>
+          </a:xfrm>
+          <a:prstGeom prst="rect">
+            <a:avLst/>
+          </a:prstGeom>
+          <a:solidFill>
+            <a:srgbClr val="1A243E"/>
+          </a:solidFill>
+          <a:ln>
+            <a:noFill/>
+          </a:ln>
+        </p:spPr>
+        <p:style>
+          <a:lnRef idx="1">
+            <a:schemeClr val="accent1"/>
+          </a:lnRef>
+          <a:fillRef idx="3">
+            <a:schemeClr val="accent1"/>
+          </a:fillRef>
+          <a:effectRef idx="2">
+            <a:schemeClr val="accent1"/>
+          </a:effectRef>
+          <a:fontRef idx="minor">
+            <a:schemeClr val="lt1"/>
+          </a:fontRef>
+        </p:style>
+        <p:txBody>
+          <a:bodyPr rtlCol="0" anchor="ctr"/>
+          <a:lstStyle/>
+          <a:p>
+            <a:pPr algn="ctr"/>
+            <a:endParaRPr/>
+          </a:p>
+        </p:txBody>
+      </p:sp>
+      <p:sp>
+        <p:nvSpPr>
+          <p:cNvPr id="5" name="TextBox 4"/>
+          <p:cNvSpPr txBox="1"/>
+          <p:nvPr/>
+        </p:nvSpPr>
+        <p:spPr>
+          <a:xfrm>
+            <a:off x="457200" y="1645920"/>
+            <a:ext cx="10972800" cy="914400"/>
+          </a:xfrm>
+          <a:prstGeom prst="rect">
+            <a:avLst/>
+          </a:prstGeom>
+          <a:noFill/>
+        </p:spPr>
+        <p:txBody>
+          <a:bodyPr wrap="square">
+            <a:spAutoFit/>
+          </a:bodyPr>
+          <a:lstStyle/>
+          <a:p>
+            <a:pPr algn="ctr"/>
+            <a:r>
+              <a:rPr sz="5400" b="1">
+                <a:solidFill>
+                  <a:srgbClr val="FFFFFF"/>
+                </a:solidFill>
+              </a:rPr>
+              <a:t>AgentForge</a:t>
+            </a:r>
+          </a:p>
+        </p:txBody>
+      </p:sp>
+      <p:sp>
+        <p:nvSpPr>
+          <p:cNvPr id="6" name="TextBox 5"/>
+          <p:cNvSpPr txBox="1"/>
+          <p:nvPr/>
+        </p:nvSpPr>
+        <p:spPr>
+          <a:xfrm>
+            <a:off x="457200" y="2606040"/>
+            <a:ext cx="10972800" cy="731520"/>
+          </a:xfrm>
+          <a:prstGeom prst="rect">
+            <a:avLst/>
+          </a:prstGeom>
+          <a:noFill/>
+        </p:spPr>
+        <p:txBody>
+          <a:bodyPr wrap="square">
+            <a:spAutoFit/>
+          </a:bodyPr>
+          <a:lstStyle/>
+          <a:p>
+            <a:pPr algn="ctr"/>
+            <a:r>
+              <a:rPr sz="2200" b="0">
+                <a:solidFill>
+                  <a:srgbClr val="CBD5E1"/>
+                </a:solidFill>
+              </a:rPr>
+              <a:t>Build the next generation of enterprise AI agents — today.</a:t>
+            </a:r>
+          </a:p>
+        </p:txBody>
+      </p:sp>
+      <p:sp>
+        <p:nvSpPr>
+          <p:cNvPr id="7" name="Rectangle 6"/>
+          <p:cNvSpPr/>
+          <p:nvPr/>
+        </p:nvSpPr>
+        <p:spPr>
+          <a:xfrm>
+            <a:off x="1371600" y="3657600"/>
+            <a:ext cx="2834640" cy="777240"/>
+          </a:xfrm>
+          <a:prstGeom prst="rect">
+            <a:avLst/>
+          </a:prstGeom>
+          <a:solidFill>
+            <a:srgbClr val="606EF5"/>
+          </a:solidFill>
+          <a:ln>
+            <a:noFill/>
+          </a:ln>
+        </p:spPr>
+        <p:style>
+          <a:lnRef idx="1">
+            <a:schemeClr val="accent1"/>
+          </a:lnRef>
+          <a:fillRef idx="3">
+            <a:schemeClr val="accent1"/>
+          </a:fillRef>
+          <a:effectRef idx="2">
+            <a:schemeClr val="accent1"/>
+          </a:effectRef>
+          <a:fontRef idx="minor">
+            <a:schemeClr val="lt1"/>
+          </a:fontRef>
+        </p:style>
+        <p:txBody>
+          <a:bodyPr rtlCol="0" anchor="ctr"/>
+          <a:lstStyle/>
+          <a:p>
+            <a:pPr algn="ctr"/>
+            <a:endParaRPr/>
+          </a:p>
+        </p:txBody>
+      </p:sp>
+      <p:sp>
+        <p:nvSpPr>
+          <p:cNvPr id="8" name="TextBox 7"/>
+          <p:cNvSpPr txBox="1"/>
+          <p:nvPr/>
+        </p:nvSpPr>
+        <p:spPr>
+          <a:xfrm>
+            <a:off x="1371600" y="3703320"/>
+            <a:ext cx="2834640" cy="384048"/>
+          </a:xfrm>
+          <a:prstGeom prst="rect">
+            <a:avLst/>
+          </a:prstGeom>
+          <a:noFill/>
+        </p:spPr>
+        <p:txBody>
+          <a:bodyPr wrap="square">
+            <a:spAutoFit/>
+          </a:bodyPr>
+          <a:lstStyle/>
+          <a:p>
+            <a:pPr algn="ctr"/>
+            <a:r>
+              <a:rPr sz="1400" b="1">
+                <a:solidFill>
+                  <a:srgbClr val="FFFFFF"/>
+                </a:solidFill>
+              </a:rPr>
+              <a:t>🚀  Start Building</a:t>
+            </a:r>
+          </a:p>
+        </p:txBody>
+      </p:sp>
+      <p:sp>
+        <p:nvSpPr>
+          <p:cNvPr id="9" name="TextBox 8"/>
+          <p:cNvSpPr txBox="1"/>
+          <p:nvPr/>
+        </p:nvSpPr>
+        <p:spPr>
+          <a:xfrm>
+            <a:off x="1371600" y="4087368"/>
+            <a:ext cx="2834640" cy="320040"/>
+          </a:xfrm>
+          <a:prstGeom prst="rect">
+            <a:avLst/>
+          </a:prstGeom>
+          <a:noFill/>
+        </p:spPr>
+        <p:txBody>
+          <a:bodyPr wrap="square">
+            <a:spAutoFit/>
+          </a:bodyPr>
+          <a:lstStyle/>
+          <a:p>
+            <a:pPr algn="ctr"/>
+            <a:r>
+              <a:rPr sz="1100" b="0">
+                <a:solidFill>
+                  <a:srgbClr val="FFFFFF"/>
+                </a:solidFill>
+              </a:rPr>
+              <a:t>localhost:5173/architect</a:t>
+            </a:r>
+          </a:p>
+        </p:txBody>
+      </p:sp>
+      <p:sp>
+        <p:nvSpPr>
+          <p:cNvPr id="10" name="Rectangle 9"/>
+          <p:cNvSpPr/>
+          <p:nvPr/>
+        </p:nvSpPr>
+        <p:spPr>
+          <a:xfrm>
+            <a:off x="4572000" y="3657600"/>
+            <a:ext cx="2834640" cy="777240"/>
+          </a:xfrm>
+          <a:prstGeom prst="rect">
+            <a:avLst/>
+          </a:prstGeom>
+          <a:solidFill>
+            <a:srgbClr val="10B981"/>
+          </a:solidFill>
+          <a:ln>
+            <a:noFill/>
+          </a:ln>
+        </p:spPr>
+        <p:style>
+          <a:lnRef idx="1">
+            <a:schemeClr val="accent1"/>
+          </a:lnRef>
+          <a:fillRef idx="3">
+            <a:schemeClr val="accent1"/>
+          </a:fillRef>
+          <a:effectRef idx="2">
+            <a:schemeClr val="accent1"/>
+          </a:effectRef>
+          <a:fontRef idx="minor">
+            <a:schemeClr val="lt1"/>
+          </a:fontRef>
+        </p:style>
+        <p:txBody>
+          <a:bodyPr rtlCol="0" anchor="ctr"/>
+          <a:lstStyle/>
+          <a:p>
+            <a:pPr algn="ctr"/>
+            <a:endParaRPr/>
+          </a:p>
+        </p:txBody>
+      </p:sp>
+      <p:sp>
+        <p:nvSpPr>
+          <p:cNvPr id="11" name="TextBox 10"/>
+          <p:cNvSpPr txBox="1"/>
+          <p:nvPr/>
+        </p:nvSpPr>
+        <p:spPr>
+          <a:xfrm>
+            <a:off x="4572000" y="3703320"/>
+            <a:ext cx="2834640" cy="384048"/>
+          </a:xfrm>
+          <a:prstGeom prst="rect">
+            <a:avLst/>
+          </a:prstGeom>
+          <a:noFill/>
+        </p:spPr>
+        <p:txBody>
+          <a:bodyPr wrap="square">
+            <a:spAutoFit/>
+          </a:bodyPr>
+          <a:lstStyle/>
+          <a:p>
+            <a:pPr algn="ctr"/>
+            <a:r>
+              <a:rPr sz="1400" b="1">
+                <a:solidFill>
+                  <a:srgbClr val="FFFFFF"/>
+                </a:solidFill>
+              </a:rPr>
+              <a:t>📖  API Docs</a:t>
+            </a:r>
+          </a:p>
+        </p:txBody>
+      </p:sp>
+      <p:sp>
+        <p:nvSpPr>
+          <p:cNvPr id="12" name="TextBox 11"/>
+          <p:cNvSpPr txBox="1"/>
+          <p:nvPr/>
+        </p:nvSpPr>
+        <p:spPr>
+          <a:xfrm>
+            <a:off x="4572000" y="4087368"/>
+            <a:ext cx="2834640" cy="320040"/>
+          </a:xfrm>
+          <a:prstGeom prst="rect">
+            <a:avLst/>
+          </a:prstGeom>
+          <a:noFill/>
+        </p:spPr>
+        <p:txBody>
+          <a:bodyPr wrap="square">
+            <a:spAutoFit/>
+          </a:bodyPr>
+          <a:lstStyle/>
+          <a:p>
+            <a:pPr algn="ctr"/>
+            <a:r>
+              <a:rPr sz="1100" b="0">
+                <a:solidFill>
+                  <a:srgbClr val="FFFFFF"/>
+                </a:solidFill>
+              </a:rPr>
+              <a:t>localhost:8000/docs</a:t>
+            </a:r>
+          </a:p>
+        </p:txBody>
+      </p:sp>
+      <p:sp>
+        <p:nvSpPr>
+          <p:cNvPr id="13" name="Rectangle 12"/>
+          <p:cNvSpPr/>
+          <p:nvPr/>
+        </p:nvSpPr>
+        <p:spPr>
+          <a:xfrm>
+            <a:off x="7772400" y="3657600"/>
+            <a:ext cx="2834640" cy="777240"/>
+          </a:xfrm>
+          <a:prstGeom prst="rect">
+            <a:avLst/>
+          </a:prstGeom>
+          <a:solidFill>
+            <a:srgbClr val="F59E0B"/>
+          </a:solidFill>
+          <a:ln>
+            <a:noFill/>
+          </a:ln>
+        </p:spPr>
+        <p:style>
+          <a:lnRef idx="1">
+            <a:schemeClr val="accent1"/>
+          </a:lnRef>
+          <a:fillRef idx="3">
+            <a:schemeClr val="accent1"/>
+          </a:fillRef>
+          <a:effectRef idx="2">
+            <a:schemeClr val="accent1"/>
+          </a:effectRef>
+          <a:fontRef idx="minor">
+            <a:schemeClr val="lt1"/>
+          </a:fontRef>
+        </p:style>
+        <p:txBody>
+          <a:bodyPr rtlCol="0" anchor="ctr"/>
+          <a:lstStyle/>
+          <a:p>
+            <a:pPr algn="ctr"/>
+            <a:endParaRPr/>
+          </a:p>
+        </p:txBody>
+      </p:sp>
+      <p:sp>
+        <p:nvSpPr>
+          <p:cNvPr id="14" name="TextBox 13"/>
+          <p:cNvSpPr txBox="1"/>
+          <p:nvPr/>
+        </p:nvSpPr>
+        <p:spPr>
+          <a:xfrm>
+            <a:off x="7772400" y="3703320"/>
+            <a:ext cx="2834640" cy="384048"/>
+          </a:xfrm>
+          <a:prstGeom prst="rect">
+            <a:avLst/>
+          </a:prstGeom>
+          <a:noFill/>
+        </p:spPr>
+        <p:txBody>
+          <a:bodyPr wrap="square">
+            <a:spAutoFit/>
+          </a:bodyPr>
+          <a:lstStyle/>
+          <a:p>
+            <a:pPr algn="ctr"/>
+            <a:r>
+              <a:rPr sz="1400" b="1">
+                <a:solidFill>
+                  <a:srgbClr val="FFFFFF"/>
+                </a:solidFill>
+              </a:rPr>
+              <a:t>📦  Download ZIP</a:t>
+            </a:r>
+          </a:p>
+        </p:txBody>
+      </p:sp>
+      <p:sp>
+        <p:nvSpPr>
+          <p:cNvPr id="15" name="TextBox 14"/>
+          <p:cNvSpPr txBox="1"/>
+          <p:nvPr/>
+        </p:nvSpPr>
+        <p:spPr>
+          <a:xfrm>
+            <a:off x="7772400" y="4087368"/>
+            <a:ext cx="2834640" cy="320040"/>
+          </a:xfrm>
+          <a:prstGeom prst="rect">
+            <a:avLst/>
+          </a:prstGeom>
+          <a:noFill/>
+        </p:spPr>
+        <p:txBody>
+          <a:bodyPr wrap="square">
+            <a:spAutoFit/>
+          </a:bodyPr>
+          <a:lstStyle/>
+          <a:p>
+            <a:pPr algn="ctr"/>
+            <a:r>
+              <a:rPr sz="1100" b="0">
+                <a:solidFill>
+                  <a:srgbClr val="FFFFFF"/>
+                </a:solidFill>
+              </a:rPr>
+              <a:t>Architect → App → Download</a:t>
+            </a:r>
+          </a:p>
+        </p:txBody>
+      </p:sp>
+      <p:sp>
+        <p:nvSpPr>
+          <p:cNvPr id="16" name="TextBox 15"/>
+          <p:cNvSpPr txBox="1"/>
+          <p:nvPr/>
+        </p:nvSpPr>
+        <p:spPr>
+          <a:xfrm>
+            <a:off x="457200" y="5760720"/>
+            <a:ext cx="10972800" cy="365760"/>
+          </a:xfrm>
+          <a:prstGeom prst="rect">
+            <a:avLst/>
+          </a:prstGeom>
+          <a:noFill/>
+        </p:spPr>
+        <p:txBody>
+          <a:bodyPr wrap="square">
+            <a:spAutoFit/>
+          </a:bodyPr>
+          <a:lstStyle/>
+          <a:p>
+            <a:pPr algn="ctr"/>
+            <a:r>
+              <a:rPr sz="1200" b="0">
+                <a:solidFill>
+                  <a:srgbClr val="CBD5E1"/>
+                </a:solidFill>
+              </a:rPr>
+              <a:t>Accenture Technology  |  n.sureshmanikandan@accenture.com  |  Confidential</a:t>
+            </a:r>
+          </a:p>
+        </p:txBody>
+      </p:sp>
+      <p:sp>
+        <p:nvSpPr>
+          <p:cNvPr id="17" name="TextBox 16"/>
+          <p:cNvSpPr txBox="1"/>
+          <p:nvPr/>
+        </p:nvSpPr>
+        <p:spPr>
+          <a:xfrm>
+            <a:off x="11640312" y="6492240"/>
+            <a:ext cx="457200" cy="320040"/>
+          </a:xfrm>
+          <a:prstGeom prst="rect">
+            <a:avLst/>
+          </a:prstGeom>
+          <a:noFill/>
+        </p:spPr>
+        <p:txBody>
+          <a:bodyPr wrap="square">
+            <a:spAutoFit/>
+          </a:bodyPr>
+          <a:lstStyle/>
+          <a:p>
+            <a:pPr algn="r"/>
+            <a:r>
+              <a:rPr sz="1100" b="0">
+                <a:solidFill>
+                  <a:srgbClr val="CBD5E1"/>
+                </a:solidFill>
+              </a:rPr>
+              <a:t>37</a:t>
             </a:r>
           </a:p>
         </p:txBody>
@@ -34702,7 +35591,7 @@
         </p:nvSpPr>
         <p:spPr>
           <a:xfrm>
-            <a:off x="457200" y="1097280"/>
+            <a:off x="457200" y="987552"/>
             <a:ext cx="2560320" cy="457200"/>
           </a:xfrm>
           <a:prstGeom prst="rect">
@@ -34718,7 +35607,7 @@
           <a:p>
             <a:pPr algn="l"/>
             <a:r>
-              <a:rPr sz="1500" b="1">
+              <a:rPr sz="1500" b="1" dirty="0">
                 <a:solidFill>
                   <a:srgbClr val="606EF5"/>
                 </a:solidFill>
@@ -34926,7 +35815,7 @@
         </p:nvSpPr>
         <p:spPr>
           <a:xfrm>
-            <a:off x="6419088" y="1097280"/>
+            <a:off x="6419088" y="978408"/>
             <a:ext cx="2560320" cy="457200"/>
           </a:xfrm>
           <a:prstGeom prst="rect">
@@ -34942,7 +35831,7 @@
           <a:p>
             <a:pPr algn="l"/>
             <a:r>
-              <a:rPr sz="1500" b="1">
+              <a:rPr sz="1500" b="1" dirty="0">
                 <a:solidFill>
                   <a:srgbClr val="606EF5"/>
                 </a:solidFill>
@@ -35150,7 +36039,7 @@
         </p:nvSpPr>
         <p:spPr>
           <a:xfrm>
-            <a:off x="457200" y="2880360"/>
+            <a:off x="457200" y="2761488"/>
             <a:ext cx="2560320" cy="457200"/>
           </a:xfrm>
           <a:prstGeom prst="rect">
@@ -35166,7 +36055,7 @@
           <a:p>
             <a:pPr algn="l"/>
             <a:r>
-              <a:rPr sz="1500" b="1">
+              <a:rPr sz="1500" b="1" dirty="0">
                 <a:solidFill>
                   <a:srgbClr val="606EF5"/>
                 </a:solidFill>
@@ -35374,7 +36263,7 @@
         </p:nvSpPr>
         <p:spPr>
           <a:xfrm>
-            <a:off x="6419088" y="2880360"/>
+            <a:off x="6419088" y="2766060"/>
             <a:ext cx="2560320" cy="457200"/>
           </a:xfrm>
           <a:prstGeom prst="rect">
@@ -35390,7 +36279,7 @@
           <a:p>
             <a:pPr algn="l"/>
             <a:r>
-              <a:rPr sz="1500" b="1">
+              <a:rPr sz="1500" b="1" dirty="0">
                 <a:solidFill>
                   <a:srgbClr val="606EF5"/>
                 </a:solidFill>
@@ -35486,7 +36375,7 @@
         </p:nvSpPr>
         <p:spPr>
           <a:xfrm>
-            <a:off x="9400032" y="2880360"/>
+            <a:off x="9400032" y="2756916"/>
             <a:ext cx="2560320" cy="457200"/>
           </a:xfrm>
           <a:prstGeom prst="rect">
@@ -35502,7 +36391,7 @@
           <a:p>
             <a:pPr algn="l"/>
             <a:r>
-              <a:rPr sz="1500" b="1">
+              <a:rPr sz="1500" b="1" dirty="0">
                 <a:solidFill>
                   <a:srgbClr val="606EF5"/>
                 </a:solidFill>
@@ -35598,7 +36487,7 @@
         </p:nvSpPr>
         <p:spPr>
           <a:xfrm>
-            <a:off x="457200" y="4663440"/>
+            <a:off x="457200" y="4517136"/>
             <a:ext cx="2560320" cy="457200"/>
           </a:xfrm>
           <a:prstGeom prst="rect">
@@ -35614,7 +36503,7 @@
           <a:p>
             <a:pPr algn="l"/>
             <a:r>
-              <a:rPr sz="1500" b="1">
+              <a:rPr sz="1500" b="1" dirty="0">
                 <a:solidFill>
                   <a:srgbClr val="606EF5"/>
                 </a:solidFill>
@@ -35822,7 +36711,7 @@
         </p:nvSpPr>
         <p:spPr>
           <a:xfrm>
-            <a:off x="6419088" y="4663440"/>
+            <a:off x="6419088" y="4549140"/>
             <a:ext cx="2560320" cy="457200"/>
           </a:xfrm>
           <a:prstGeom prst="rect">
@@ -35838,7 +36727,7 @@
           <a:p>
             <a:pPr algn="l"/>
             <a:r>
-              <a:rPr sz="1500" b="1">
+              <a:rPr sz="1500" b="1" dirty="0">
                 <a:solidFill>
                   <a:srgbClr val="606EF5"/>
                 </a:solidFill>
@@ -35934,7 +36823,7 @@
         </p:nvSpPr>
         <p:spPr>
           <a:xfrm>
-            <a:off x="9400032" y="4663440"/>
+            <a:off x="9400032" y="4539996"/>
             <a:ext cx="2560320" cy="457200"/>
           </a:xfrm>
           <a:prstGeom prst="rect">
@@ -35950,7 +36839,7 @@
           <a:p>
             <a:pPr algn="l"/>
             <a:r>
-              <a:rPr sz="1500" b="1">
+              <a:rPr sz="1500" b="1" dirty="0">
                 <a:solidFill>
                   <a:srgbClr val="606EF5"/>
                 </a:solidFill>
@@ -36261,7 +37150,7 @@
         </p:nvSpPr>
         <p:spPr>
           <a:xfrm>
-            <a:off x="502920" y="1508760"/>
+            <a:off x="1979676" y="1280160"/>
             <a:ext cx="1371600" cy="640080"/>
           </a:xfrm>
           <a:prstGeom prst="rect">
@@ -36277,7 +37166,7 @@
           <a:p>
             <a:pPr algn="l"/>
             <a:r>
-              <a:rPr sz="3600" b="1">
+              <a:rPr sz="3600" b="1" dirty="0">
                 <a:solidFill>
                   <a:srgbClr val="FFFFFF"/>
                 </a:solidFill>
@@ -36981,7 +37870,7 @@
         </p:nvSpPr>
         <p:spPr>
           <a:xfrm>
-            <a:off x="4434840" y="3566160"/>
+            <a:off x="5966460" y="3291840"/>
             <a:ext cx="1371600" cy="640080"/>
           </a:xfrm>
           <a:prstGeom prst="rect">
@@ -36997,7 +37886,7 @@
           <a:p>
             <a:pPr algn="l"/>
             <a:r>
-              <a:rPr sz="3600" b="1">
+              <a:rPr sz="3600" b="1" dirty="0">
                 <a:solidFill>
                   <a:srgbClr val="FFFFFF"/>
                 </a:solidFill>

</xml_diff>